<commit_message>
fix(presentation): resolve confusion matrix title overlap & format topic intros with exact What/Why/Where/How bullet structure
</commit_message>
<xml_diff>
--- a/Review2_ByteBrigades_LoanDefault.pptx
+++ b/Review2_ByteBrigades_LoanDefault.pptx
@@ -6,19 +6,19 @@
   </p:sldMasterIdLst>
   <p:sldIdLst>
     <p:sldId id="256" r:id="rId7"/>
-    <p:sldId id="257" r:id="rId9"/>
-    <p:sldId id="258" r:id="rId10"/>
-    <p:sldId id="259" r:id="rId11"/>
-    <p:sldId id="260" r:id="rId12"/>
-    <p:sldId id="261" r:id="rId13"/>
-    <p:sldId id="262" r:id="rId14"/>
-    <p:sldId id="263" r:id="rId15"/>
-    <p:sldId id="264" r:id="rId16"/>
-    <p:sldId id="265" r:id="rId17"/>
-    <p:sldId id="266" r:id="rId18"/>
-    <p:sldId id="267" r:id="rId19"/>
-    <p:sldId id="268" r:id="rId20"/>
-    <p:sldId id="269" r:id="rId21"/>
+    <p:sldId id="257" r:id="rId8"/>
+    <p:sldId id="258" r:id="rId9"/>
+    <p:sldId id="259" r:id="rId10"/>
+    <p:sldId id="260" r:id="rId11"/>
+    <p:sldId id="261" r:id="rId12"/>
+    <p:sldId id="262" r:id="rId13"/>
+    <p:sldId id="263" r:id="rId14"/>
+    <p:sldId id="264" r:id="rId15"/>
+    <p:sldId id="265" r:id="rId16"/>
+    <p:sldId id="266" r:id="rId17"/>
+    <p:sldId id="267" r:id="rId18"/>
+    <p:sldId id="268" r:id="rId19"/>
+    <p:sldId id="269" r:id="rId20"/>
   </p:sldIdLst>
   <p:sldSz cx="12191695" cy="6858000" type="screen4x3"/>
   <p:notesSz cx="6858000" cy="9144000"/>
@@ -118,1056 +118,6 @@
     </a:lvl9pPr>
   </p:defaultTextStyle>
 </p:presentation>
-</file>
-
-<file path=ppt/notesMasters/notesMaster1.xml><?xml version="1.0" encoding="utf-8"?>
-<p:notesMaster xmlns:a="http://schemas.openxmlformats.org/drawingml/2006/main" xmlns:p="http://schemas.openxmlformats.org/presentationml/2006/main" xmlns:r="http://schemas.openxmlformats.org/officeDocument/2006/relationships">
-  <p:cSld>
-    <p:bg>
-      <p:bgRef idx="1001">
-        <a:schemeClr val="bg1"/>
-      </p:bgRef>
-    </p:bg>
-    <p:spTree>
-      <p:nvGrpSpPr>
-        <p:cNvPr id="1" name=""/>
-        <p:cNvGrpSpPr/>
-        <p:nvPr/>
-      </p:nvGrpSpPr>
-      <p:grpSpPr>
-        <a:xfrm>
-          <a:off x="0" y="0"/>
-          <a:ext cx="0" cy="0"/>
-          <a:chOff x="0" y="0"/>
-          <a:chExt cx="0" cy="0"/>
-        </a:xfrm>
-      </p:grpSpPr>
-      <p:sp>
-        <p:nvSpPr>
-          <p:cNvPr id="2" name="Header Placeholder 1"/>
-          <p:cNvSpPr>
-            <a:spLocks noGrp="1"/>
-          </p:cNvSpPr>
-          <p:nvPr>
-            <p:ph type="hdr" sz="quarter"/>
-          </p:nvPr>
-        </p:nvSpPr>
-        <p:spPr>
-          <a:xfrm>
-            <a:off x="0" y="0"/>
-            <a:ext cx="2971800" cy="457200"/>
-          </a:xfrm>
-          <a:prstGeom prst="rect">
-            <a:avLst/>
-          </a:prstGeom>
-        </p:spPr>
-        <p:txBody>
-          <a:bodyPr vert="horz" lIns="91440" tIns="45720" rIns="91440" bIns="45720" rtlCol="0"/>
-          <a:lstStyle>
-            <a:lvl1pPr algn="l">
-              <a:defRPr sz="1200"/>
-            </a:lvl1pPr>
-          </a:lstStyle>
-          <a:p>
-            <a:endParaRPr lang="en-US"/>
-          </a:p>
-        </p:txBody>
-      </p:sp>
-      <p:sp>
-        <p:nvSpPr>
-          <p:cNvPr id="3" name="Date Placeholder 2"/>
-          <p:cNvSpPr>
-            <a:spLocks noGrp="1"/>
-          </p:cNvSpPr>
-          <p:nvPr>
-            <p:ph type="dt" idx="1"/>
-          </p:nvPr>
-        </p:nvSpPr>
-        <p:spPr>
-          <a:xfrm>
-            <a:off x="3884613" y="0"/>
-            <a:ext cx="2971800" cy="457200"/>
-          </a:xfrm>
-          <a:prstGeom prst="rect">
-            <a:avLst/>
-          </a:prstGeom>
-        </p:spPr>
-        <p:txBody>
-          <a:bodyPr vert="horz" lIns="91440" tIns="45720" rIns="91440" bIns="45720" rtlCol="0"/>
-          <a:lstStyle>
-            <a:lvl1pPr algn="r">
-              <a:defRPr sz="1200"/>
-            </a:lvl1pPr>
-          </a:lstStyle>
-          <a:p>
-            <a:fld id="{0F89C1C7-3DCD-1040-A9CF-14679D8B5DDD}" type="datetimeFigureOut">
-              <a:rPr lang="en-US" smtClean="0"/>
-              <a:t>10/17/16</a:t>
-            </a:fld>
-            <a:endParaRPr lang="en-US"/>
-          </a:p>
-        </p:txBody>
-      </p:sp>
-      <p:sp>
-        <p:nvSpPr>
-          <p:cNvPr id="4" name="Slide Image Placeholder 3"/>
-          <p:cNvSpPr>
-            <a:spLocks noGrp="1" noRot="1" noChangeAspect="1"/>
-          </p:cNvSpPr>
-          <p:nvPr>
-            <p:ph type="sldImg" idx="2"/>
-          </p:nvPr>
-        </p:nvSpPr>
-        <p:spPr>
-          <a:xfrm>
-            <a:off x="1143000" y="685800"/>
-            <a:ext cx="4572000" cy="3429000"/>
-          </a:xfrm>
-          <a:prstGeom prst="rect">
-            <a:avLst/>
-          </a:prstGeom>
-          <a:noFill/>
-          <a:ln w="12700">
-            <a:solidFill>
-              <a:prstClr val="black"/>
-            </a:solidFill>
-          </a:ln>
-        </p:spPr>
-        <p:txBody>
-          <a:bodyPr vert="horz" lIns="91440" tIns="45720" rIns="91440" bIns="45720" rtlCol="0" anchor="ctr"/>
-          <a:lstStyle/>
-          <a:p>
-            <a:endParaRPr lang="en-US"/>
-          </a:p>
-        </p:txBody>
-      </p:sp>
-      <p:sp>
-        <p:nvSpPr>
-          <p:cNvPr id="5" name="Notes Placeholder 4"/>
-          <p:cNvSpPr>
-            <a:spLocks noGrp="1"/>
-          </p:cNvSpPr>
-          <p:nvPr>
-            <p:ph type="body" sz="quarter" idx="3"/>
-          </p:nvPr>
-        </p:nvSpPr>
-        <p:spPr>
-          <a:xfrm>
-            <a:off x="685800" y="4343400"/>
-            <a:ext cx="5486400" cy="4114800"/>
-          </a:xfrm>
-          <a:prstGeom prst="rect">
-            <a:avLst/>
-          </a:prstGeom>
-        </p:spPr>
-        <p:txBody>
-          <a:bodyPr vert="horz" lIns="91440" tIns="45720" rIns="91440" bIns="45720" rtlCol="0"/>
-          <a:lstStyle/>
-          <a:p>
-            <a:pPr lvl="0"/>
-            <a:r>
-              <a:rPr lang="en-US" smtClean="0"/>
-              <a:t>Click to edit Master text styles</a:t>
-            </a:r>
-          </a:p>
-          <a:p>
-            <a:pPr lvl="1"/>
-            <a:r>
-              <a:rPr lang="en-US" smtClean="0"/>
-              <a:t>Second level</a:t>
-            </a:r>
-          </a:p>
-          <a:p>
-            <a:pPr lvl="2"/>
-            <a:r>
-              <a:rPr lang="en-US" smtClean="0"/>
-              <a:t>Third level</a:t>
-            </a:r>
-          </a:p>
-          <a:p>
-            <a:pPr lvl="3"/>
-            <a:r>
-              <a:rPr lang="en-US" smtClean="0"/>
-              <a:t>Fourth level</a:t>
-            </a:r>
-          </a:p>
-          <a:p>
-            <a:pPr lvl="4"/>
-            <a:r>
-              <a:rPr lang="en-US" smtClean="0"/>
-              <a:t>Fifth level</a:t>
-            </a:r>
-            <a:endParaRPr lang="en-US"/>
-          </a:p>
-        </p:txBody>
-      </p:sp>
-      <p:sp>
-        <p:nvSpPr>
-          <p:cNvPr id="6" name="Footer Placeholder 5"/>
-          <p:cNvSpPr>
-            <a:spLocks noGrp="1"/>
-          </p:cNvSpPr>
-          <p:nvPr>
-            <p:ph type="ftr" sz="quarter" idx="4"/>
-          </p:nvPr>
-        </p:nvSpPr>
-        <p:spPr>
-          <a:xfrm>
-            <a:off x="0" y="8685213"/>
-            <a:ext cx="2971800" cy="457200"/>
-          </a:xfrm>
-          <a:prstGeom prst="rect">
-            <a:avLst/>
-          </a:prstGeom>
-        </p:spPr>
-        <p:txBody>
-          <a:bodyPr vert="horz" lIns="91440" tIns="45720" rIns="91440" bIns="45720" rtlCol="0" anchor="b"/>
-          <a:lstStyle>
-            <a:lvl1pPr algn="l">
-              <a:defRPr sz="1200"/>
-            </a:lvl1pPr>
-          </a:lstStyle>
-          <a:p>
-            <a:endParaRPr lang="en-US"/>
-          </a:p>
-        </p:txBody>
-      </p:sp>
-      <p:sp>
-        <p:nvSpPr>
-          <p:cNvPr id="7" name="Slide Number Placeholder 6"/>
-          <p:cNvSpPr>
-            <a:spLocks noGrp="1"/>
-          </p:cNvSpPr>
-          <p:nvPr>
-            <p:ph type="sldNum" sz="quarter" idx="5"/>
-          </p:nvPr>
-        </p:nvSpPr>
-        <p:spPr>
-          <a:xfrm>
-            <a:off x="3884613" y="8685213"/>
-            <a:ext cx="2971800" cy="457200"/>
-          </a:xfrm>
-          <a:prstGeom prst="rect">
-            <a:avLst/>
-          </a:prstGeom>
-        </p:spPr>
-        <p:txBody>
-          <a:bodyPr vert="horz" lIns="91440" tIns="45720" rIns="91440" bIns="45720" rtlCol="0" anchor="b"/>
-          <a:lstStyle>
-            <a:lvl1pPr algn="r">
-              <a:defRPr sz="1200"/>
-            </a:lvl1pPr>
-          </a:lstStyle>
-          <a:p>
-            <a:fld id="{BB5E49A5-4136-284D-997B-48E1D791AD67}" type="slidenum">
-              <a:rPr lang="en-US" smtClean="0"/>
-              <a:t>‹#›</a:t>
-            </a:fld>
-            <a:endParaRPr lang="en-US"/>
-          </a:p>
-        </p:txBody>
-      </p:sp>
-    </p:spTree>
-    <p:extLst>
-      <p:ext uri="{BB962C8B-B14F-4D97-AF65-F5344CB8AC3E}">
-        <p14:creationId xmlns:p14="http://schemas.microsoft.com/office/powerpoint/2010/main" val="2623252185"/>
-      </p:ext>
-    </p:extLst>
-  </p:cSld>
-  <p:clrMap bg1="lt1" tx1="dk1" bg2="lt2" tx2="dk2" accent1="accent1" accent2="accent2" accent3="accent3" accent4="accent4" accent5="accent5" accent6="accent6" hlink="hlink" folHlink="folHlink"/>
-  <p:notesStyle>
-    <a:lvl1pPr marL="0" algn="l" defTabSz="457200" rtl="0" eaLnBrk="1" latinLnBrk="0" hangingPunct="1">
-      <a:defRPr sz="1200" kern="1200">
-        <a:solidFill>
-          <a:schemeClr val="tx1"/>
-        </a:solidFill>
-        <a:latin typeface="+mn-lt"/>
-        <a:ea typeface="+mn-ea"/>
-        <a:cs typeface="+mn-cs"/>
-      </a:defRPr>
-    </a:lvl1pPr>
-    <a:lvl2pPr marL="457200" algn="l" defTabSz="457200" rtl="0" eaLnBrk="1" latinLnBrk="0" hangingPunct="1">
-      <a:defRPr sz="1200" kern="1200">
-        <a:solidFill>
-          <a:schemeClr val="tx1"/>
-        </a:solidFill>
-        <a:latin typeface="+mn-lt"/>
-        <a:ea typeface="+mn-ea"/>
-        <a:cs typeface="+mn-cs"/>
-      </a:defRPr>
-    </a:lvl2pPr>
-    <a:lvl3pPr marL="914400" algn="l" defTabSz="457200" rtl="0" eaLnBrk="1" latinLnBrk="0" hangingPunct="1">
-      <a:defRPr sz="1200" kern="1200">
-        <a:solidFill>
-          <a:schemeClr val="tx1"/>
-        </a:solidFill>
-        <a:latin typeface="+mn-lt"/>
-        <a:ea typeface="+mn-ea"/>
-        <a:cs typeface="+mn-cs"/>
-      </a:defRPr>
-    </a:lvl3pPr>
-    <a:lvl4pPr marL="1371600" algn="l" defTabSz="457200" rtl="0" eaLnBrk="1" latinLnBrk="0" hangingPunct="1">
-      <a:defRPr sz="1200" kern="1200">
-        <a:solidFill>
-          <a:schemeClr val="tx1"/>
-        </a:solidFill>
-        <a:latin typeface="+mn-lt"/>
-        <a:ea typeface="+mn-ea"/>
-        <a:cs typeface="+mn-cs"/>
-      </a:defRPr>
-    </a:lvl4pPr>
-    <a:lvl5pPr marL="1828800" algn="l" defTabSz="457200" rtl="0" eaLnBrk="1" latinLnBrk="0" hangingPunct="1">
-      <a:defRPr sz="1200" kern="1200">
-        <a:solidFill>
-          <a:schemeClr val="tx1"/>
-        </a:solidFill>
-        <a:latin typeface="+mn-lt"/>
-        <a:ea typeface="+mn-ea"/>
-        <a:cs typeface="+mn-cs"/>
-      </a:defRPr>
-    </a:lvl5pPr>
-    <a:lvl6pPr marL="2286000" algn="l" defTabSz="457200" rtl="0" eaLnBrk="1" latinLnBrk="0" hangingPunct="1">
-      <a:defRPr sz="1200" kern="1200">
-        <a:solidFill>
-          <a:schemeClr val="tx1"/>
-        </a:solidFill>
-        <a:latin typeface="+mn-lt"/>
-        <a:ea typeface="+mn-ea"/>
-        <a:cs typeface="+mn-cs"/>
-      </a:defRPr>
-    </a:lvl6pPr>
-    <a:lvl7pPr marL="2743200" algn="l" defTabSz="457200" rtl="0" eaLnBrk="1" latinLnBrk="0" hangingPunct="1">
-      <a:defRPr sz="1200" kern="1200">
-        <a:solidFill>
-          <a:schemeClr val="tx1"/>
-        </a:solidFill>
-        <a:latin typeface="+mn-lt"/>
-        <a:ea typeface="+mn-ea"/>
-        <a:cs typeface="+mn-cs"/>
-      </a:defRPr>
-    </a:lvl7pPr>
-    <a:lvl8pPr marL="3200400" algn="l" defTabSz="457200" rtl="0" eaLnBrk="1" latinLnBrk="0" hangingPunct="1">
-      <a:defRPr sz="1200" kern="1200">
-        <a:solidFill>
-          <a:schemeClr val="tx1"/>
-        </a:solidFill>
-        <a:latin typeface="+mn-lt"/>
-        <a:ea typeface="+mn-ea"/>
-        <a:cs typeface="+mn-cs"/>
-      </a:defRPr>
-    </a:lvl8pPr>
-    <a:lvl9pPr marL="3657600" algn="l" defTabSz="457200" rtl="0" eaLnBrk="1" latinLnBrk="0" hangingPunct="1">
-      <a:defRPr sz="1200" kern="1200">
-        <a:solidFill>
-          <a:schemeClr val="tx1"/>
-        </a:solidFill>
-        <a:latin typeface="+mn-lt"/>
-        <a:ea typeface="+mn-ea"/>
-        <a:cs typeface="+mn-cs"/>
-      </a:defRPr>
-    </a:lvl9pPr>
-  </p:notesStyle>
-</p:notesMaster>
-</file>
-
-<file path=ppt/notesSlides/notesSlide1.xml><?xml version="1.0" encoding="utf-8"?>
-<p:notes xmlns:a="http://schemas.openxmlformats.org/drawingml/2006/main" xmlns:p="http://schemas.openxmlformats.org/presentationml/2006/main" xmlns:r="http://schemas.openxmlformats.org/officeDocument/2006/relationships">
-  <p:cSld>
-    <p:spTree>
-      <p:nvGrpSpPr>
-        <p:cNvPr id="1" name=""/>
-        <p:cNvGrpSpPr/>
-        <p:nvPr/>
-      </p:nvGrpSpPr>
-      <p:grpSpPr>
-        <a:xfrm>
-          <a:off x="0" y="0"/>
-          <a:ext cx="0" cy="0"/>
-          <a:chOff x="0" y="0"/>
-          <a:chExt cx="0" cy="0"/>
-        </a:xfrm>
-      </p:grpSpPr>
-      <p:sp>
-        <p:nvSpPr>
-          <p:cNvPr id="2" name="Slide Image Placeholder 1"/>
-          <p:cNvSpPr>
-            <a:spLocks noGrp="1"/>
-          </p:cNvSpPr>
-          <p:nvPr>
-            <p:ph type="sldImg" idx="2"/>
-          </p:nvPr>
-        </p:nvSpPr>
-        <p:spPr/>
-      </p:sp>
-      <p:sp>
-        <p:nvSpPr>
-          <p:cNvPr id="3" name="Notes Placeholder 2"/>
-          <p:cNvSpPr>
-            <a:spLocks noGrp="1"/>
-          </p:cNvSpPr>
-          <p:nvPr>
-            <p:ph type="body" idx="3" sz="quarter"/>
-          </p:nvPr>
-        </p:nvSpPr>
-        <p:spPr/>
-        <p:txBody>
-          <a:bodyPr/>
-          <a:lstStyle/>
-          <a:p>
-            <a:r>
-              <a:t>Good morning faculty. We are team Byte Brigades presenting Review 2 for CSI3010 Data Warehousing &amp; Data Mining. Our team members are Mahaprabhu K (24MID0109) and Pavithran O (24MID0144). Today we present the four core data mining deliverables: Classification, Clustering, Association Rules, and Default Prediction.</a:t>
-            </a:r>
-          </a:p>
-        </p:txBody>
-      </p:sp>
-      <p:sp>
-        <p:nvSpPr>
-          <p:cNvPr id="4" name="Slide Number Placeholder 3"/>
-          <p:cNvSpPr>
-            <a:spLocks noGrp="1"/>
-          </p:cNvSpPr>
-          <p:nvPr>
-            <p:ph type="sldNum" idx="5" sz="quarter"/>
-          </p:nvPr>
-        </p:nvSpPr>
-        <p:spPr/>
-      </p:sp>
-    </p:spTree>
-  </p:cSld>
-  <p:clrMapOvr>
-    <a:masterClrMapping/>
-  </p:clrMapOvr>
-</p:notes>
-</file>
-
-<file path=ppt/notesSlides/notesSlide10.xml><?xml version="1.0" encoding="utf-8"?>
-<p:notes xmlns:a="http://schemas.openxmlformats.org/drawingml/2006/main" xmlns:p="http://schemas.openxmlformats.org/presentationml/2006/main" xmlns:r="http://schemas.openxmlformats.org/officeDocument/2006/relationships">
-  <p:cSld>
-    <p:spTree>
-      <p:nvGrpSpPr>
-        <p:cNvPr id="1" name=""/>
-        <p:cNvGrpSpPr/>
-        <p:nvPr/>
-      </p:nvGrpSpPr>
-      <p:grpSpPr>
-        <a:xfrm>
-          <a:off x="0" y="0"/>
-          <a:ext cx="0" cy="0"/>
-          <a:chOff x="0" y="0"/>
-          <a:chExt cx="0" cy="0"/>
-        </a:xfrm>
-      </p:grpSpPr>
-      <p:sp>
-        <p:nvSpPr>
-          <p:cNvPr id="2" name="Slide Image Placeholder 1"/>
-          <p:cNvSpPr>
-            <a:spLocks noGrp="1"/>
-          </p:cNvSpPr>
-          <p:nvPr>
-            <p:ph type="sldImg" idx="2"/>
-          </p:nvPr>
-        </p:nvSpPr>
-        <p:spPr/>
-      </p:sp>
-      <p:sp>
-        <p:nvSpPr>
-          <p:cNvPr id="3" name="Notes Placeholder 2"/>
-          <p:cNvSpPr>
-            <a:spLocks noGrp="1"/>
-          </p:cNvSpPr>
-          <p:nvPr>
-            <p:ph type="body" idx="3" sz="quarter"/>
-          </p:nvPr>
-        </p:nvSpPr>
-        <p:spPr/>
-        <p:txBody>
-          <a:bodyPr/>
-          <a:lstStyle/>
-          <a:p>
-            <a:r>
-              <a:t>In summary, all four required components of Review 2 are fully completed and verified. In Review 3 we will demonstrate the live interactive dashboard and real-time simulator. Thank you faculty, we are ready for your questions.</a:t>
-            </a:r>
-          </a:p>
-        </p:txBody>
-      </p:sp>
-      <p:sp>
-        <p:nvSpPr>
-          <p:cNvPr id="4" name="Slide Number Placeholder 3"/>
-          <p:cNvSpPr>
-            <a:spLocks noGrp="1"/>
-          </p:cNvSpPr>
-          <p:nvPr>
-            <p:ph type="sldNum" idx="5" sz="quarter"/>
-          </p:nvPr>
-        </p:nvSpPr>
-        <p:spPr/>
-      </p:sp>
-    </p:spTree>
-  </p:cSld>
-  <p:clrMapOvr>
-    <a:masterClrMapping/>
-  </p:clrMapOvr>
-</p:notes>
-</file>
-
-<file path=ppt/notesSlides/notesSlide2.xml><?xml version="1.0" encoding="utf-8"?>
-<p:notes xmlns:a="http://schemas.openxmlformats.org/drawingml/2006/main" xmlns:p="http://schemas.openxmlformats.org/presentationml/2006/main" xmlns:r="http://schemas.openxmlformats.org/officeDocument/2006/relationships">
-  <p:cSld>
-    <p:spTree>
-      <p:nvGrpSpPr>
-        <p:cNvPr id="1" name=""/>
-        <p:cNvGrpSpPr/>
-        <p:nvPr/>
-      </p:nvGrpSpPr>
-      <p:grpSpPr>
-        <a:xfrm>
-          <a:off x="0" y="0"/>
-          <a:ext cx="0" cy="0"/>
-          <a:chOff x="0" y="0"/>
-          <a:chExt cx="0" cy="0"/>
-        </a:xfrm>
-      </p:grpSpPr>
-      <p:sp>
-        <p:nvSpPr>
-          <p:cNvPr id="2" name="Slide Image Placeholder 1"/>
-          <p:cNvSpPr>
-            <a:spLocks noGrp="1"/>
-          </p:cNvSpPr>
-          <p:nvPr>
-            <p:ph type="sldImg" idx="2"/>
-          </p:nvPr>
-        </p:nvSpPr>
-        <p:spPr/>
-      </p:sp>
-      <p:sp>
-        <p:nvSpPr>
-          <p:cNvPr id="3" name="Notes Placeholder 2"/>
-          <p:cNvSpPr>
-            <a:spLocks noGrp="1"/>
-          </p:cNvSpPr>
-          <p:nvPr>
-            <p:ph type="body" idx="3" sz="quarter"/>
-          </p:nvPr>
-        </p:nvSpPr>
-        <p:spPr/>
-        <p:txBody>
-          <a:bodyPr/>
-          <a:lstStyle/>
-          <a:p>
-            <a:r>
-              <a:t>Here is the dataset profile. With 50,000 records, defaults represent only 11.7%. A naive model predicting zero defaults achieves 88% accuracy while failing completely. Hence our evaluation strictly prioritizes Recall, F1-Score, and ROC-AUC.</a:t>
-            </a:r>
-          </a:p>
-        </p:txBody>
-      </p:sp>
-      <p:sp>
-        <p:nvSpPr>
-          <p:cNvPr id="4" name="Slide Number Placeholder 3"/>
-          <p:cNvSpPr>
-            <a:spLocks noGrp="1"/>
-          </p:cNvSpPr>
-          <p:nvPr>
-            <p:ph type="sldNum" idx="5" sz="quarter"/>
-          </p:nvPr>
-        </p:nvSpPr>
-        <p:spPr/>
-      </p:sp>
-    </p:spTree>
-  </p:cSld>
-  <p:clrMapOvr>
-    <a:masterClrMapping/>
-  </p:clrMapOvr>
-</p:notes>
-</file>
-
-<file path=ppt/notesSlides/notesSlide3.xml><?xml version="1.0" encoding="utf-8"?>
-<p:notes xmlns:a="http://schemas.openxmlformats.org/drawingml/2006/main" xmlns:p="http://schemas.openxmlformats.org/presentationml/2006/main" xmlns:r="http://schemas.openxmlformats.org/officeDocument/2006/relationships">
-  <p:cSld>
-    <p:spTree>
-      <p:nvGrpSpPr>
-        <p:cNvPr id="1" name=""/>
-        <p:cNvGrpSpPr/>
-        <p:nvPr/>
-      </p:nvGrpSpPr>
-      <p:grpSpPr>
-        <a:xfrm>
-          <a:off x="0" y="0"/>
-          <a:ext cx="0" cy="0"/>
-          <a:chOff x="0" y="0"/>
-          <a:chExt cx="0" cy="0"/>
-        </a:xfrm>
-      </p:grpSpPr>
-      <p:sp>
-        <p:nvSpPr>
-          <p:cNvPr id="2" name="Slide Image Placeholder 1"/>
-          <p:cNvSpPr>
-            <a:spLocks noGrp="1"/>
-          </p:cNvSpPr>
-          <p:nvPr>
-            <p:ph type="sldImg" idx="2"/>
-          </p:nvPr>
-        </p:nvSpPr>
-        <p:spPr/>
-      </p:sp>
-      <p:sp>
-        <p:nvSpPr>
-          <p:cNvPr id="3" name="Notes Placeholder 2"/>
-          <p:cNvSpPr>
-            <a:spLocks noGrp="1"/>
-          </p:cNvSpPr>
-          <p:nvPr>
-            <p:ph type="body" idx="3" sz="quarter"/>
-          </p:nvPr>
-        </p:nvSpPr>
-        <p:spPr/>
-        <p:txBody>
-          <a:bodyPr/>
-          <a:lstStyle/>
-          <a:p>
-            <a:r>
-              <a:t>Here is the training code and test set benchmark. Logistic regression provides high recall but generates too many false alarms (57% precision). Gradient Boosting achieved 97.11% precision and 83.25% recall, with a champion F1-score of 0.8965 and 0.9973 ROC-AUC.</a:t>
-            </a:r>
-          </a:p>
-        </p:txBody>
-      </p:sp>
-      <p:sp>
-        <p:nvSpPr>
-          <p:cNvPr id="4" name="Slide Number Placeholder 3"/>
-          <p:cNvSpPr>
-            <a:spLocks noGrp="1"/>
-          </p:cNvSpPr>
-          <p:nvPr>
-            <p:ph type="sldNum" idx="5" sz="quarter"/>
-          </p:nvPr>
-        </p:nvSpPr>
-        <p:spPr/>
-      </p:sp>
-    </p:spTree>
-  </p:cSld>
-  <p:clrMapOvr>
-    <a:masterClrMapping/>
-  </p:clrMapOvr>
-</p:notes>
-</file>
-
-<file path=ppt/notesSlides/notesSlide4.xml><?xml version="1.0" encoding="utf-8"?>
-<p:notes xmlns:a="http://schemas.openxmlformats.org/drawingml/2006/main" xmlns:p="http://schemas.openxmlformats.org/presentationml/2006/main" xmlns:r="http://schemas.openxmlformats.org/officeDocument/2006/relationships">
-  <p:cSld>
-    <p:spTree>
-      <p:nvGrpSpPr>
-        <p:cNvPr id="1" name=""/>
-        <p:cNvGrpSpPr/>
-        <p:nvPr/>
-      </p:nvGrpSpPr>
-      <p:grpSpPr>
-        <a:xfrm>
-          <a:off x="0" y="0"/>
-          <a:ext cx="0" cy="0"/>
-          <a:chOff x="0" y="0"/>
-          <a:chExt cx="0" cy="0"/>
-        </a:xfrm>
-      </p:grpSpPr>
-      <p:sp>
-        <p:nvSpPr>
-          <p:cNvPr id="2" name="Slide Image Placeholder 1"/>
-          <p:cNvSpPr>
-            <a:spLocks noGrp="1"/>
-          </p:cNvSpPr>
-          <p:nvPr>
-            <p:ph type="sldImg" idx="2"/>
-          </p:nvPr>
-        </p:nvSpPr>
-        <p:spPr/>
-      </p:sp>
-      <p:sp>
-        <p:nvSpPr>
-          <p:cNvPr id="3" name="Notes Placeholder 2"/>
-          <p:cNvSpPr>
-            <a:spLocks noGrp="1"/>
-          </p:cNvSpPr>
-          <p:nvPr>
-            <p:ph type="body" idx="3" sz="quarter"/>
-          </p:nvPr>
-        </p:nvSpPr>
-        <p:spPr/>
-        <p:txBody>
-          <a:bodyPr/>
-          <a:lstStyle/>
-          <a:p>
-            <a:r>
-              <a:t>The pictorial diagnostics show our four models. The confusion matrix heatmaps show Gradient Boosting maintains minimal false positives. The ROC curves confirm near-optimal probability separation across all decision thresholds.</a:t>
-            </a:r>
-          </a:p>
-        </p:txBody>
-      </p:sp>
-      <p:sp>
-        <p:nvSpPr>
-          <p:cNvPr id="4" name="Slide Number Placeholder 3"/>
-          <p:cNvSpPr>
-            <a:spLocks noGrp="1"/>
-          </p:cNvSpPr>
-          <p:nvPr>
-            <p:ph type="sldNum" idx="5" sz="quarter"/>
-          </p:nvPr>
-        </p:nvSpPr>
-        <p:spPr/>
-      </p:sp>
-    </p:spTree>
-  </p:cSld>
-  <p:clrMapOvr>
-    <a:masterClrMapping/>
-  </p:clrMapOvr>
-</p:notes>
-</file>
-
-<file path=ppt/notesSlides/notesSlide5.xml><?xml version="1.0" encoding="utf-8"?>
-<p:notes xmlns:a="http://schemas.openxmlformats.org/drawingml/2006/main" xmlns:p="http://schemas.openxmlformats.org/presentationml/2006/main" xmlns:r="http://schemas.openxmlformats.org/officeDocument/2006/relationships">
-  <p:cSld>
-    <p:spTree>
-      <p:nvGrpSpPr>
-        <p:cNvPr id="1" name=""/>
-        <p:cNvGrpSpPr/>
-        <p:nvPr/>
-      </p:nvGrpSpPr>
-      <p:grpSpPr>
-        <a:xfrm>
-          <a:off x="0" y="0"/>
-          <a:ext cx="0" cy="0"/>
-          <a:chOff x="0" y="0"/>
-          <a:chExt cx="0" cy="0"/>
-        </a:xfrm>
-      </p:grpSpPr>
-      <p:sp>
-        <p:nvSpPr>
-          <p:cNvPr id="2" name="Slide Image Placeholder 1"/>
-          <p:cNvSpPr>
-            <a:spLocks noGrp="1"/>
-          </p:cNvSpPr>
-          <p:nvPr>
-            <p:ph type="sldImg" idx="2"/>
-          </p:nvPr>
-        </p:nvSpPr>
-        <p:spPr/>
-      </p:sp>
-      <p:sp>
-        <p:nvSpPr>
-          <p:cNvPr id="3" name="Notes Placeholder 2"/>
-          <p:cNvSpPr>
-            <a:spLocks noGrp="1"/>
-          </p:cNvSpPr>
-          <p:nvPr>
-            <p:ph type="body" idx="3" sz="quarter"/>
-          </p:nvPr>
-        </p:nvSpPr>
-        <p:spPr/>
-        <p:txBody>
-          <a:bodyPr/>
-          <a:lstStyle/>
-          <a:p>
-            <a:r>
-              <a:t>Here is our clustering implementation. We standardized 5 core financial features and ran K-Means across K=2 to 6. The Elbow plot exhibits an inflection point at K=3, creating three distinct risk archetypes.</a:t>
-            </a:r>
-          </a:p>
-        </p:txBody>
-      </p:sp>
-      <p:sp>
-        <p:nvSpPr>
-          <p:cNvPr id="4" name="Slide Number Placeholder 3"/>
-          <p:cNvSpPr>
-            <a:spLocks noGrp="1"/>
-          </p:cNvSpPr>
-          <p:nvPr>
-            <p:ph type="sldNum" idx="5" sz="quarter"/>
-          </p:nvPr>
-        </p:nvSpPr>
-        <p:spPr/>
-      </p:sp>
-    </p:spTree>
-  </p:cSld>
-  <p:clrMapOvr>
-    <a:masterClrMapping/>
-  </p:clrMapOvr>
-</p:notes>
-</file>
-
-<file path=ppt/notesSlides/notesSlide6.xml><?xml version="1.0" encoding="utf-8"?>
-<p:notes xmlns:a="http://schemas.openxmlformats.org/drawingml/2006/main" xmlns:p="http://schemas.openxmlformats.org/presentationml/2006/main" xmlns:r="http://schemas.openxmlformats.org/officeDocument/2006/relationships">
-  <p:cSld>
-    <p:spTree>
-      <p:nvGrpSpPr>
-        <p:cNvPr id="1" name=""/>
-        <p:cNvGrpSpPr/>
-        <p:nvPr/>
-      </p:nvGrpSpPr>
-      <p:grpSpPr>
-        <a:xfrm>
-          <a:off x="0" y="0"/>
-          <a:ext cx="0" cy="0"/>
-          <a:chOff x="0" y="0"/>
-          <a:chExt cx="0" cy="0"/>
-        </a:xfrm>
-      </p:grpSpPr>
-      <p:sp>
-        <p:nvSpPr>
-          <p:cNvPr id="2" name="Slide Image Placeholder 1"/>
-          <p:cNvSpPr>
-            <a:spLocks noGrp="1"/>
-          </p:cNvSpPr>
-          <p:nvPr>
-            <p:ph type="sldImg" idx="2"/>
-          </p:nvPr>
-        </p:nvSpPr>
-        <p:spPr/>
-      </p:sp>
-      <p:sp>
-        <p:nvSpPr>
-          <p:cNvPr id="3" name="Notes Placeholder 2"/>
-          <p:cNvSpPr>
-            <a:spLocks noGrp="1"/>
-          </p:cNvSpPr>
-          <p:nvPr>
-            <p:ph type="body" idx="3" sz="quarter"/>
-          </p:nvPr>
-        </p:nvSpPr>
-        <p:spPr/>
-        <p:txBody>
-          <a:bodyPr/>
-          <a:lstStyle/>
-          <a:p>
-            <a:r>
-              <a:t>Here are the mined borrower profiles alongside the 2D PCA projection. Cluster 2 represents Prime borrowers with a default rate of only 3.93%. Cluster 0 isolates vulnerable borrowers where default reaches 20.36%.</a:t>
-            </a:r>
-          </a:p>
-        </p:txBody>
-      </p:sp>
-      <p:sp>
-        <p:nvSpPr>
-          <p:cNvPr id="4" name="Slide Number Placeholder 3"/>
-          <p:cNvSpPr>
-            <a:spLocks noGrp="1"/>
-          </p:cNvSpPr>
-          <p:nvPr>
-            <p:ph type="sldNum" idx="5" sz="quarter"/>
-          </p:nvPr>
-        </p:nvSpPr>
-        <p:spPr/>
-      </p:sp>
-    </p:spTree>
-  </p:cSld>
-  <p:clrMapOvr>
-    <a:masterClrMapping/>
-  </p:clrMapOvr>
-</p:notes>
-</file>
-
-<file path=ppt/notesSlides/notesSlide7.xml><?xml version="1.0" encoding="utf-8"?>
-<p:notes xmlns:a="http://schemas.openxmlformats.org/drawingml/2006/main" xmlns:p="http://schemas.openxmlformats.org/presentationml/2006/main" xmlns:r="http://schemas.openxmlformats.org/officeDocument/2006/relationships">
-  <p:cSld>
-    <p:spTree>
-      <p:nvGrpSpPr>
-        <p:cNvPr id="1" name=""/>
-        <p:cNvGrpSpPr/>
-        <p:nvPr/>
-      </p:nvGrpSpPr>
-      <p:grpSpPr>
-        <a:xfrm>
-          <a:off x="0" y="0"/>
-          <a:ext cx="0" cy="0"/>
-          <a:chOff x="0" y="0"/>
-          <a:chExt cx="0" cy="0"/>
-        </a:xfrm>
-      </p:grpSpPr>
-      <p:sp>
-        <p:nvSpPr>
-          <p:cNvPr id="2" name="Slide Image Placeholder 1"/>
-          <p:cNvSpPr>
-            <a:spLocks noGrp="1"/>
-          </p:cNvSpPr>
-          <p:nvPr>
-            <p:ph type="sldImg" idx="2"/>
-          </p:nvPr>
-        </p:nvSpPr>
-        <p:spPr/>
-      </p:sp>
-      <p:sp>
-        <p:nvSpPr>
-          <p:cNvPr id="3" name="Notes Placeholder 2"/>
-          <p:cNvSpPr>
-            <a:spLocks noGrp="1"/>
-          </p:cNvSpPr>
-          <p:nvPr>
-            <p:ph type="body" idx="3" sz="quarter"/>
-          </p:nvPr>
-        </p:nvSpPr>
-        <p:spPr/>
-        <p:txBody>
-          <a:bodyPr/>
-          <a:lstStyle/>
-          <a:p>
-            <a:r>
-              <a:t>To apply the Apriori algorithm, continuous numerical features were converted to categorical bins. We set a minimum support of 3% and confidence of 30%, filtering specifically for rules leading to Default=Yes. Lift indicates the multiplicative default risk increase above baseline.</a:t>
-            </a:r>
-          </a:p>
-        </p:txBody>
-      </p:sp>
-      <p:sp>
-        <p:nvSpPr>
-          <p:cNvPr id="4" name="Slide Number Placeholder 3"/>
-          <p:cNvSpPr>
-            <a:spLocks noGrp="1"/>
-          </p:cNvSpPr>
-          <p:nvPr>
-            <p:ph type="sldNum" idx="5" sz="quarter"/>
-          </p:nvPr>
-        </p:nvSpPr>
-        <p:spPr/>
-      </p:sp>
-    </p:spTree>
-  </p:cSld>
-  <p:clrMapOvr>
-    <a:masterClrMapping/>
-  </p:clrMapOvr>
-</p:notes>
-</file>
-
-<file path=ppt/notesSlides/notesSlide8.xml><?xml version="1.0" encoding="utf-8"?>
-<p:notes xmlns:a="http://schemas.openxmlformats.org/drawingml/2006/main" xmlns:p="http://schemas.openxmlformats.org/presentationml/2006/main" xmlns:r="http://schemas.openxmlformats.org/officeDocument/2006/relationships">
-  <p:cSld>
-    <p:spTree>
-      <p:nvGrpSpPr>
-        <p:cNvPr id="1" name=""/>
-        <p:cNvGrpSpPr/>
-        <p:nvPr/>
-      </p:nvGrpSpPr>
-      <p:grpSpPr>
-        <a:xfrm>
-          <a:off x="0" y="0"/>
-          <a:ext cx="0" cy="0"/>
-          <a:chOff x="0" y="0"/>
-          <a:chExt cx="0" cy="0"/>
-        </a:xfrm>
-      </p:grpSpPr>
-      <p:sp>
-        <p:nvSpPr>
-          <p:cNvPr id="2" name="Slide Image Placeholder 1"/>
-          <p:cNvSpPr>
-            <a:spLocks noGrp="1"/>
-          </p:cNvSpPr>
-          <p:nvPr>
-            <p:ph type="sldImg" idx="2"/>
-          </p:nvPr>
-        </p:nvSpPr>
-        <p:spPr/>
-      </p:sp>
-      <p:sp>
-        <p:nvSpPr>
-          <p:cNvPr id="3" name="Notes Placeholder 2"/>
-          <p:cNvSpPr>
-            <a:spLocks noGrp="1"/>
-          </p:cNvSpPr>
-          <p:nvPr>
-            <p:ph type="body" idx="3" sz="quarter"/>
-          </p:nvPr>
-        </p:nvSpPr>
-        <p:spPr/>
-        <p:txBody>
-          <a:bodyPr/>
-          <a:lstStyle/>
-          <a:p>
-            <a:r>
-              <a:t>Here is the pictorial representation of our mined association rules. Rule 1 exhibits a Lift of 5.69x with 66.93% confidence when low income, poor credit, and large loan amount co-occur. Rule 3 shows that lacking a co-signer under high DTI drives default risk over 54%.</a:t>
-            </a:r>
-          </a:p>
-        </p:txBody>
-      </p:sp>
-      <p:sp>
-        <p:nvSpPr>
-          <p:cNvPr id="4" name="Slide Number Placeholder 3"/>
-          <p:cNvSpPr>
-            <a:spLocks noGrp="1"/>
-          </p:cNvSpPr>
-          <p:nvPr>
-            <p:ph type="sldNum" idx="5" sz="quarter"/>
-          </p:nvPr>
-        </p:nvSpPr>
-        <p:spPr/>
-      </p:sp>
-    </p:spTree>
-  </p:cSld>
-  <p:clrMapOvr>
-    <a:masterClrMapping/>
-  </p:clrMapOvr>
-</p:notes>
-</file>
-
-<file path=ppt/notesSlides/notesSlide9.xml><?xml version="1.0" encoding="utf-8"?>
-<p:notes xmlns:a="http://schemas.openxmlformats.org/drawingml/2006/main" xmlns:p="http://schemas.openxmlformats.org/presentationml/2006/main" xmlns:r="http://schemas.openxmlformats.org/officeDocument/2006/relationships">
-  <p:cSld>
-    <p:spTree>
-      <p:nvGrpSpPr>
-        <p:cNvPr id="1" name=""/>
-        <p:cNvGrpSpPr/>
-        <p:nvPr/>
-      </p:nvGrpSpPr>
-      <p:grpSpPr>
-        <a:xfrm>
-          <a:off x="0" y="0"/>
-          <a:ext cx="0" cy="0"/>
-          <a:chOff x="0" y="0"/>
-          <a:chExt cx="0" cy="0"/>
-        </a:xfrm>
-      </p:grpSpPr>
-      <p:sp>
-        <p:nvSpPr>
-          <p:cNvPr id="2" name="Slide Image Placeholder 1"/>
-          <p:cNvSpPr>
-            <a:spLocks noGrp="1"/>
-          </p:cNvSpPr>
-          <p:nvPr>
-            <p:ph type="sldImg" idx="2"/>
-          </p:nvPr>
-        </p:nvSpPr>
-        <p:spPr/>
-      </p:sp>
-      <p:sp>
-        <p:nvSpPr>
-          <p:cNvPr id="3" name="Notes Placeholder 2"/>
-          <p:cNvSpPr>
-            <a:spLocks noGrp="1"/>
-          </p:cNvSpPr>
-          <p:nvPr>
-            <p:ph type="body" idx="3" sz="quarter"/>
-          </p:nvPr>
-        </p:nvSpPr>
-        <p:spPr/>
-        <p:txBody>
-          <a:bodyPr/>
-          <a:lstStyle/>
-          <a:p>
-            <a:r>
-              <a:t>Here is our prediction engine implementation. We transform borrower payloads and compute continuous probabilities P(Default=1). Our Brier score of 0.0168 confirms the probabilities are highly calibrated, enabling a clear 4-tier risk policy.</a:t>
-            </a:r>
-          </a:p>
-        </p:txBody>
-      </p:sp>
-      <p:sp>
-        <p:nvSpPr>
-          <p:cNvPr id="4" name="Slide Number Placeholder 3"/>
-          <p:cNvSpPr>
-            <a:spLocks noGrp="1"/>
-          </p:cNvSpPr>
-          <p:nvPr>
-            <p:ph type="sldNum" idx="5" sz="quarter"/>
-          </p:nvPr>
-        </p:nvSpPr>
-        <p:spPr/>
-      </p:sp>
-    </p:spTree>
-  </p:cSld>
-  <p:clrMapOvr>
-    <a:masterClrMapping/>
-  </p:clrMapOvr>
-</p:notes>
 </file>
 
 <file path=ppt/slideLayouts/slideLayout1.xml><?xml version="1.0" encoding="utf-8"?>
@@ -5677,7 +4627,7 @@
               </a:defRPr>
             </a:pPr>
             <a:r>
-              <a:t>CSI3010 | MODULE 4: PREDICTION</a:t>
+              <a:t>CSI3010 | TOPIC OVERVIEW &amp; INSTITUTIONAL ROLE</a:t>
             </a:r>
           </a:p>
         </p:txBody>
@@ -5713,7 +4663,7 @@
               </a:defRPr>
             </a:pPr>
             <a:r>
-              <a:t>Topic 4: Prediction — Concept &amp; Institutional Role</a:t>
+              <a:t>Overview: Prediction Engine</a:t>
             </a:r>
           </a:p>
         </p:txBody>
@@ -5727,7 +4677,191 @@
         <p:spPr>
           <a:xfrm>
             <a:off x="731520" y="1188720"/>
-            <a:ext cx="5212080" cy="2514600"/>
+            <a:ext cx="10728655" cy="3931920"/>
+          </a:xfrm>
+          <a:prstGeom prst="roundRect">
+            <a:avLst/>
+          </a:prstGeom>
+          <a:solidFill>
+            <a:srgbClr val="FFFFFF"/>
+          </a:solidFill>
+          <a:ln w="12700">
+            <a:solidFill>
+              <a:srgbClr val="2563EB"/>
+            </a:solidFill>
+          </a:ln>
+        </p:spPr>
+        <p:style>
+          <a:lnRef idx="1">
+            <a:schemeClr val="accent1"/>
+          </a:lnRef>
+          <a:fillRef idx="3">
+            <a:schemeClr val="accent1"/>
+          </a:fillRef>
+          <a:effectRef idx="2">
+            <a:schemeClr val="accent1"/>
+          </a:effectRef>
+          <a:fontRef idx="minor">
+            <a:schemeClr val="lt1"/>
+          </a:fontRef>
+        </p:style>
+        <p:txBody>
+          <a:bodyPr rtlCol="0" anchor="ctr"/>
+          <a:lstStyle/>
+          <a:p>
+            <a:pPr algn="ctr"/>
+          </a:p>
+        </p:txBody>
+      </p:sp>
+      <p:sp>
+        <p:nvSpPr>
+          <p:cNvPr id="6" name="TextBox 5"/>
+          <p:cNvSpPr txBox="1"/>
+          <p:nvPr/>
+        </p:nvSpPr>
+        <p:spPr>
+          <a:xfrm>
+            <a:off x="1005840" y="1371600"/>
+            <a:ext cx="10180015" cy="3566160"/>
+          </a:xfrm>
+          <a:prstGeom prst="rect">
+            <a:avLst/>
+          </a:prstGeom>
+          <a:noFill/>
+        </p:spPr>
+        <p:txBody>
+          <a:bodyPr wrap="square">
+            <a:spAutoFit/>
+          </a:bodyPr>
+          <a:lstStyle/>
+          <a:p>
+            <a:pPr>
+              <a:spcAft>
+                <a:spcPts val="1400"/>
+              </a:spcAft>
+              <a:defRPr sz="1600" b="1">
+                <a:solidFill>
+                  <a:srgbClr val="0F172A"/>
+                </a:solidFill>
+                <a:latin typeface="Segoe UI"/>
+              </a:defRPr>
+            </a:pPr>
+            <a:r>
+              <a:t>Heading: Prediction Engine</a:t>
+            </a:r>
+          </a:p>
+          <a:p>
+            <a:pPr>
+              <a:spcAft>
+                <a:spcPts val="1400"/>
+              </a:spcAft>
+              <a:defRPr sz="1200" b="1">
+                <a:solidFill>
+                  <a:srgbClr val="2563EB"/>
+                </a:solidFill>
+                <a:latin typeface="Segoe UI"/>
+              </a:defRPr>
+            </a:pPr>
+            <a:r>
+              <a:t>• What it is: </a:t>
+            </a:r>
+            <a:r>
+              <a:rPr sz="1200" b="0">
+                <a:solidFill>
+                  <a:srgbClr val="334155"/>
+                </a:solidFill>
+                <a:latin typeface="Segoe UI"/>
+              </a:rPr>
+              <a:t>Probabilistic inference engine computing continuous probability scores P(Default=1) in range [0.0, 1.0] for any applicant payload.</a:t>
+            </a:r>
+          </a:p>
+          <a:p>
+            <a:pPr>
+              <a:spcAft>
+                <a:spcPts val="1400"/>
+              </a:spcAft>
+              <a:defRPr sz="1200" b="1">
+                <a:solidFill>
+                  <a:srgbClr val="2563EB"/>
+                </a:solidFill>
+                <a:latin typeface="Segoe UI"/>
+              </a:defRPr>
+            </a:pPr>
+            <a:r>
+              <a:t>• Why it is needed: </a:t>
+            </a:r>
+            <a:r>
+              <a:rPr sz="1200" b="0">
+                <a:solidFill>
+                  <a:srgbClr val="334155"/>
+                </a:solidFill>
+                <a:latin typeface="Segoe UI"/>
+              </a:rPr>
+              <a:t>Real-world credit underwriting requires granular probability scores rather than rigid 0/1 binary labels for dynamic risk pricing.</a:t>
+            </a:r>
+          </a:p>
+          <a:p>
+            <a:pPr>
+              <a:spcAft>
+                <a:spcPts val="1400"/>
+              </a:spcAft>
+              <a:defRPr sz="1200" b="1">
+                <a:solidFill>
+                  <a:srgbClr val="2563EB"/>
+                </a:solidFill>
+                <a:latin typeface="Segoe UI"/>
+              </a:defRPr>
+            </a:pPr>
+            <a:r>
+              <a:t>• Where it is used: </a:t>
+            </a:r>
+            <a:r>
+              <a:rPr sz="1200" b="0">
+                <a:solidFill>
+                  <a:srgbClr val="334155"/>
+                </a:solidFill>
+                <a:latin typeface="Segoe UI"/>
+              </a:rPr>
+              <a:t>Integrated into automated loan pricing engines, regulatory capital calculations, and live applicant simulator forms.</a:t>
+            </a:r>
+          </a:p>
+          <a:p>
+            <a:pPr>
+              <a:spcAft>
+                <a:spcPts val="1400"/>
+              </a:spcAft>
+              <a:defRPr sz="1200" b="1">
+                <a:solidFill>
+                  <a:srgbClr val="2563EB"/>
+                </a:solidFill>
+                <a:latin typeface="Segoe UI"/>
+              </a:defRPr>
+            </a:pPr>
+            <a:r>
+              <a:t>• How it is helpful: </a:t>
+            </a:r>
+            <a:r>
+              <a:rPr sz="1200" b="0">
+                <a:solidFill>
+                  <a:srgbClr val="334155"/>
+                </a:solidFill>
+                <a:latin typeface="Segoe UI"/>
+              </a:rPr>
+              <a:t>Maps applicants into 4 distinct policy tiers (Low, Moderate, High, Critical Risk) with an exceptional 0.0168 Brier calibration score.</a:t>
+            </a:r>
+          </a:p>
+        </p:txBody>
+      </p:sp>
+      <p:sp>
+        <p:nvSpPr>
+          <p:cNvPr id="7" name="Rounded Rectangle 6"/>
+          <p:cNvSpPr/>
+          <p:nvPr/>
+        </p:nvSpPr>
+        <p:spPr>
+          <a:xfrm>
+            <a:off x="731520" y="5303520"/>
+            <a:ext cx="10728655" cy="1051560"/>
           </a:xfrm>
           <a:prstGeom prst="roundRect">
             <a:avLst/>
@@ -5765,14 +4899,14 @@
       </p:sp>
       <p:sp>
         <p:nvSpPr>
-          <p:cNvPr id="6" name="TextBox 5"/>
+          <p:cNvPr id="8" name="TextBox 7"/>
           <p:cNvSpPr txBox="1"/>
           <p:nvPr/>
         </p:nvSpPr>
         <p:spPr>
           <a:xfrm>
-            <a:off x="914400" y="1325880"/>
-            <a:ext cx="4846320" cy="2240280"/>
+            <a:off x="1005840" y="5394960"/>
+            <a:ext cx="10180015" cy="868680"/>
           </a:xfrm>
           <a:prstGeom prst="rect">
             <a:avLst/>
@@ -5787,9 +4921,9 @@
           <a:p>
             <a:pPr>
               <a:spcAft>
-                <a:spcPts val="800"/>
+                <a:spcPts val="200"/>
               </a:spcAft>
-              <a:defRPr sz="1300" b="1">
+              <a:defRPr sz="1200" b="1">
                 <a:solidFill>
                   <a:srgbClr val="2563EB"/>
                 </a:solidFill>
@@ -5797,451 +4931,20 @@
               </a:defRPr>
             </a:pPr>
             <a:r>
-              <a:t>1. WHY We Used It (Problem Statement)</a:t>
-            </a:r>
-          </a:p>
-          <a:p>
-            <a:pPr>
-              <a:spcAft>
-                <a:spcPts val="600"/>
-              </a:spcAft>
-              <a:defRPr sz="1200">
-                <a:solidFill>
-                  <a:srgbClr val="334155"/>
-                </a:solidFill>
-                <a:latin typeface="Segoe UI"/>
-              </a:defRPr>
-            </a:pPr>
-            <a:r>
-              <a:t>• Real-world fintech does not use binary 0/1 hard decisions; credit risk is a continuous probability.</a:t>
-            </a:r>
-          </a:p>
-          <a:p>
-            <a:pPr>
-              <a:spcAft>
-                <a:spcPts val="600"/>
-              </a:spcAft>
-              <a:defRPr sz="1200">
-                <a:solidFill>
-                  <a:srgbClr val="334155"/>
-                </a:solidFill>
-                <a:latin typeface="Segoe UI"/>
-              </a:defRPr>
-            </a:pPr>
-            <a:r>
-              <a:t>• Loan pricing, interest rates, and regulatory capital reserves require an exact probability: P(Default=1).</a:t>
-            </a:r>
-          </a:p>
-          <a:p>
-            <a:pPr>
-              <a:spcAft>
-                <a:spcPts val="600"/>
-              </a:spcAft>
-              <a:defRPr sz="1200">
-                <a:solidFill>
-                  <a:srgbClr val="334155"/>
-                </a:solidFill>
-                <a:latin typeface="Segoe UI"/>
-              </a:defRPr>
-            </a:pPr>
-            <a:r>
-              <a:t>• Borrowers with 21% risk require very different underwriting actions than those with 95% risk.</a:t>
-            </a:r>
-          </a:p>
-        </p:txBody>
-      </p:sp>
-      <p:sp>
-        <p:nvSpPr>
-          <p:cNvPr id="7" name="Rounded Rectangle 6"/>
-          <p:cNvSpPr/>
-          <p:nvPr/>
-        </p:nvSpPr>
-        <p:spPr>
-          <a:xfrm>
-            <a:off x="6217920" y="1188720"/>
-            <a:ext cx="5242255" cy="2514600"/>
-          </a:xfrm>
-          <a:prstGeom prst="roundRect">
-            <a:avLst/>
-          </a:prstGeom>
-          <a:solidFill>
-            <a:srgbClr val="ECFDF5"/>
-          </a:solidFill>
-          <a:ln w="12700">
-            <a:solidFill>
-              <a:srgbClr val="10B981"/>
-            </a:solidFill>
-          </a:ln>
-        </p:spPr>
-        <p:style>
-          <a:lnRef idx="1">
-            <a:schemeClr val="accent1"/>
-          </a:lnRef>
-          <a:fillRef idx="3">
-            <a:schemeClr val="accent1"/>
-          </a:fillRef>
-          <a:effectRef idx="2">
-            <a:schemeClr val="accent1"/>
-          </a:effectRef>
-          <a:fontRef idx="minor">
-            <a:schemeClr val="lt1"/>
-          </a:fontRef>
-        </p:style>
-        <p:txBody>
-          <a:bodyPr rtlCol="0" anchor="ctr"/>
-          <a:lstStyle/>
-          <a:p>
-            <a:pPr algn="ctr"/>
-          </a:p>
-        </p:txBody>
-      </p:sp>
-      <p:sp>
-        <p:nvSpPr>
-          <p:cNvPr id="8" name="TextBox 7"/>
-          <p:cNvSpPr txBox="1"/>
-          <p:nvPr/>
-        </p:nvSpPr>
-        <p:spPr>
-          <a:xfrm>
-            <a:off x="6400800" y="1325880"/>
-            <a:ext cx="4876495" cy="2240280"/>
-          </a:xfrm>
-          <a:prstGeom prst="rect">
-            <a:avLst/>
-          </a:prstGeom>
-          <a:noFill/>
-        </p:spPr>
-        <p:txBody>
-          <a:bodyPr wrap="square">
-            <a:spAutoFit/>
-          </a:bodyPr>
-          <a:lstStyle/>
-          <a:p>
-            <a:pPr>
-              <a:spcAft>
-                <a:spcPts val="800"/>
-              </a:spcAft>
-              <a:defRPr sz="1300" b="1">
-                <a:solidFill>
-                  <a:srgbClr val="10B981"/>
-                </a:solidFill>
-                <a:latin typeface="Segoe UI"/>
-              </a:defRPr>
-            </a:pPr>
-            <a:r>
-              <a:t>2. HOW We Used It (Pipeline &amp; Methods)</a:t>
-            </a:r>
-          </a:p>
-          <a:p>
-            <a:pPr>
-              <a:spcAft>
-                <a:spcPts val="600"/>
-              </a:spcAft>
-              <a:defRPr sz="1200">
-                <a:solidFill>
-                  <a:srgbClr val="334155"/>
-                </a:solidFill>
-                <a:latin typeface="Segoe UI"/>
-              </a:defRPr>
-            </a:pPr>
-            <a:r>
-              <a:t>• Built LoanDefaultPredictor wrapping the preprocessor and champion Gradient Boosting model.</a:t>
-            </a:r>
-          </a:p>
-          <a:p>
-            <a:pPr>
-              <a:spcAft>
-                <a:spcPts val="600"/>
-              </a:spcAft>
-              <a:defRPr sz="1200">
-                <a:solidFill>
-                  <a:srgbClr val="334155"/>
-                </a:solidFill>
-                <a:latin typeface="Segoe UI"/>
-              </a:defRPr>
-            </a:pPr>
-            <a:r>
-              <a:t>• Computes continuous probability P(Default=1) in [0.0, 1.0] for any raw borrower dictionary payload.</a:t>
-            </a:r>
-          </a:p>
-          <a:p>
-            <a:pPr>
-              <a:spcAft>
-                <a:spcPts val="600"/>
-              </a:spcAft>
-              <a:defRPr sz="1200">
-                <a:solidFill>
-                  <a:srgbClr val="334155"/>
-                </a:solidFill>
-                <a:latin typeface="Segoe UI"/>
-              </a:defRPr>
-            </a:pPr>
-            <a:r>
-              <a:t>• Evaluated probability calibration quality on test data using Brier Score Loss (0.0168) and Log Loss (0.0622).</a:t>
-            </a:r>
-          </a:p>
-        </p:txBody>
-      </p:sp>
-      <p:sp>
-        <p:nvSpPr>
-          <p:cNvPr id="9" name="Rounded Rectangle 8"/>
-          <p:cNvSpPr/>
-          <p:nvPr/>
-        </p:nvSpPr>
-        <p:spPr>
-          <a:xfrm>
-            <a:off x="731520" y="3886200"/>
-            <a:ext cx="5212080" cy="2560320"/>
-          </a:xfrm>
-          <a:prstGeom prst="roundRect">
-            <a:avLst/>
-          </a:prstGeom>
-          <a:solidFill>
-            <a:srgbClr val="FEF9C3"/>
-          </a:solidFill>
-          <a:ln w="12700">
-            <a:solidFill>
-              <a:srgbClr val="CA8A04"/>
-            </a:solidFill>
-          </a:ln>
-        </p:spPr>
-        <p:style>
-          <a:lnRef idx="1">
-            <a:schemeClr val="accent1"/>
-          </a:lnRef>
-          <a:fillRef idx="3">
-            <a:schemeClr val="accent1"/>
-          </a:fillRef>
-          <a:effectRef idx="2">
-            <a:schemeClr val="accent1"/>
-          </a:effectRef>
-          <a:fontRef idx="minor">
-            <a:schemeClr val="lt1"/>
-          </a:fontRef>
-        </p:style>
-        <p:txBody>
-          <a:bodyPr rtlCol="0" anchor="ctr"/>
-          <a:lstStyle/>
-          <a:p>
-            <a:pPr algn="ctr"/>
-          </a:p>
-        </p:txBody>
-      </p:sp>
-      <p:sp>
-        <p:nvSpPr>
-          <p:cNvPr id="10" name="TextBox 9"/>
-          <p:cNvSpPr txBox="1"/>
-          <p:nvPr/>
-        </p:nvSpPr>
-        <p:spPr>
-          <a:xfrm>
-            <a:off x="914400" y="4023360"/>
-            <a:ext cx="4846320" cy="2286000"/>
-          </a:xfrm>
-          <a:prstGeom prst="rect">
-            <a:avLst/>
-          </a:prstGeom>
-          <a:noFill/>
-        </p:spPr>
-        <p:txBody>
-          <a:bodyPr wrap="square">
-            <a:spAutoFit/>
-          </a:bodyPr>
-          <a:lstStyle/>
-          <a:p>
-            <a:pPr>
-              <a:spcAft>
-                <a:spcPts val="800"/>
-              </a:spcAft>
-              <a:defRPr sz="1300" b="1">
-                <a:solidFill>
-                  <a:srgbClr val="CA8A04"/>
-                </a:solidFill>
-                <a:latin typeface="Segoe UI"/>
-              </a:defRPr>
-            </a:pPr>
-            <a:r>
-              <a:t>3. WHAT It Does in Our Project (System Role)</a:t>
-            </a:r>
-          </a:p>
-          <a:p>
-            <a:pPr>
-              <a:spcAft>
-                <a:spcPts val="600"/>
-              </a:spcAft>
-              <a:defRPr sz="1200">
-                <a:solidFill>
-                  <a:srgbClr val="334155"/>
-                </a:solidFill>
-                <a:latin typeface="Segoe UI"/>
-              </a:defRPr>
-            </a:pPr>
-            <a:r>
-              <a:t>• Transforms raw applicant data in real time and predicts continuous default probability.</a:t>
-            </a:r>
-          </a:p>
-          <a:p>
-            <a:pPr>
-              <a:spcAft>
-                <a:spcPts val="600"/>
-              </a:spcAft>
-              <a:defRPr sz="1200">
-                <a:solidFill>
-                  <a:srgbClr val="334155"/>
-                </a:solidFill>
-                <a:latin typeface="Segoe UI"/>
-              </a:defRPr>
-            </a:pPr>
-            <a:r>
-              <a:t>• Maps probabilities into 4 clear risk tier badges: Low (&lt;20%), Moderate (20-45%), High (45-70%), Critical (&gt;=70%).</a:t>
-            </a:r>
-          </a:p>
-          <a:p>
-            <a:pPr>
-              <a:spcAft>
-                <a:spcPts val="600"/>
-              </a:spcAft>
-              <a:defRPr sz="1200">
-                <a:solidFill>
-                  <a:srgbClr val="334155"/>
-                </a:solidFill>
-                <a:latin typeface="Segoe UI"/>
-              </a:defRPr>
-            </a:pPr>
-            <a:r>
-              <a:t>• Automatically extracts specific contributing risk factors (e.g. DTI &gt; 45%, Credit &lt; 600, No Co-Signer).</a:t>
-            </a:r>
-          </a:p>
-        </p:txBody>
-      </p:sp>
-      <p:sp>
-        <p:nvSpPr>
-          <p:cNvPr id="11" name="Rounded Rectangle 10"/>
-          <p:cNvSpPr/>
-          <p:nvPr/>
-        </p:nvSpPr>
-        <p:spPr>
-          <a:xfrm>
-            <a:off x="6217920" y="3886200"/>
-            <a:ext cx="5242255" cy="2560320"/>
-          </a:xfrm>
-          <a:prstGeom prst="roundRect">
-            <a:avLst/>
-          </a:prstGeom>
-          <a:solidFill>
-            <a:srgbClr val="F5F3FF"/>
-          </a:solidFill>
-          <a:ln w="12700">
-            <a:solidFill>
-              <a:srgbClr val="9333EA"/>
-            </a:solidFill>
-          </a:ln>
-        </p:spPr>
-        <p:style>
-          <a:lnRef idx="1">
-            <a:schemeClr val="accent1"/>
-          </a:lnRef>
-          <a:fillRef idx="3">
-            <a:schemeClr val="accent1"/>
-          </a:fillRef>
-          <a:effectRef idx="2">
-            <a:schemeClr val="accent1"/>
-          </a:effectRef>
-          <a:fontRef idx="minor">
-            <a:schemeClr val="lt1"/>
-          </a:fontRef>
-        </p:style>
-        <p:txBody>
-          <a:bodyPr rtlCol="0" anchor="ctr"/>
-          <a:lstStyle/>
-          <a:p>
-            <a:pPr algn="ctr"/>
-          </a:p>
-        </p:txBody>
-      </p:sp>
-      <p:sp>
-        <p:nvSpPr>
-          <p:cNvPr id="12" name="TextBox 11"/>
-          <p:cNvSpPr txBox="1"/>
-          <p:nvPr/>
-        </p:nvSpPr>
-        <p:spPr>
-          <a:xfrm>
-            <a:off x="6400800" y="4023360"/>
-            <a:ext cx="4876495" cy="2286000"/>
-          </a:xfrm>
-          <a:prstGeom prst="rect">
-            <a:avLst/>
-          </a:prstGeom>
-          <a:noFill/>
-        </p:spPr>
-        <p:txBody>
-          <a:bodyPr wrap="square">
-            <a:spAutoFit/>
-          </a:bodyPr>
-          <a:lstStyle/>
-          <a:p>
-            <a:pPr>
-              <a:spcAft>
-                <a:spcPts val="800"/>
-              </a:spcAft>
-              <a:defRPr sz="1300" b="1">
-                <a:solidFill>
-                  <a:srgbClr val="9333EA"/>
-                </a:solidFill>
-                <a:latin typeface="Segoe UI"/>
-              </a:defRPr>
-            </a:pPr>
-            <a:r>
-              <a:t>4. PRACTICAL USE (Underwriting &amp; Business Value)</a:t>
-            </a:r>
-          </a:p>
-          <a:p>
-            <a:pPr>
-              <a:spcAft>
-                <a:spcPts val="600"/>
-              </a:spcAft>
-              <a:defRPr sz="1200">
-                <a:solidFill>
-                  <a:srgbClr val="334155"/>
-                </a:solidFill>
-                <a:latin typeface="Segoe UI"/>
-              </a:defRPr>
-            </a:pPr>
-            <a:r>
-              <a:t>• Risk-Based Loan Pricing: Low risk applicants get prime APR (4.5%); higher risk gets compensatory pricing.</a:t>
-            </a:r>
-          </a:p>
-          <a:p>
-            <a:pPr>
-              <a:spcAft>
-                <a:spcPts val="600"/>
-              </a:spcAft>
-              <a:defRPr sz="1200">
-                <a:solidFill>
-                  <a:srgbClr val="334155"/>
-                </a:solidFill>
-                <a:latin typeface="Segoe UI"/>
-              </a:defRPr>
-            </a:pPr>
-            <a:r>
-              <a:t>• Automated Adverse Action Notices: Explains to applicants exactly why their loan terms were adjusted.</a:t>
-            </a:r>
-          </a:p>
-          <a:p>
-            <a:pPr>
-              <a:spcAft>
-                <a:spcPts val="600"/>
-              </a:spcAft>
-              <a:defRPr sz="1200">
-                <a:solidFill>
-                  <a:srgbClr val="334155"/>
-                </a:solidFill>
-                <a:latin typeface="Segoe UI"/>
-              </a:defRPr>
-            </a:pPr>
-            <a:r>
-              <a:t>• Live Web Integration: Powers the interactive real-time loan underwriting simulator in Review 3.</a:t>
+              <a:t>Project Implementation: prediction/predictor.py  |  Champion Result: Brier Score: 0.0168 (Log Loss: 0.0622 | Test ROC-AUC: 0.9973)</a:t>
+            </a:r>
+          </a:p>
+          <a:p>
+            <a:pPr>
+              <a:defRPr sz="1100">
+                <a:solidFill>
+                  <a:srgbClr val="64748B"/>
+                </a:solidFill>
+                <a:latin typeface="Segoe UI"/>
+              </a:defRPr>
+            </a:pPr>
+            <a:r>
+              <a:t>Execution verified against Kaggle benchmark dataset (50,000 records, 18 financial features) with zero data leakage.</a:t>
             </a:r>
           </a:p>
         </p:txBody>
@@ -8458,7 +7161,7 @@
               </a:defRPr>
             </a:pPr>
             <a:r>
-              <a:t>CSI3010 | MODULE 1: CLASSIFICATION</a:t>
+              <a:t>CSI3010 | TOPIC OVERVIEW &amp; INSTITUTIONAL ROLE</a:t>
             </a:r>
           </a:p>
         </p:txBody>
@@ -8494,7 +7197,7 @@
               </a:defRPr>
             </a:pPr>
             <a:r>
-              <a:t>Topic 1: Classification — Concept &amp; Institutional Role</a:t>
+              <a:t>Overview: Classification</a:t>
             </a:r>
           </a:p>
         </p:txBody>
@@ -8508,7 +7211,191 @@
         <p:spPr>
           <a:xfrm>
             <a:off x="731520" y="1188720"/>
-            <a:ext cx="5212080" cy="2514600"/>
+            <a:ext cx="10728655" cy="3931920"/>
+          </a:xfrm>
+          <a:prstGeom prst="roundRect">
+            <a:avLst/>
+          </a:prstGeom>
+          <a:solidFill>
+            <a:srgbClr val="FFFFFF"/>
+          </a:solidFill>
+          <a:ln w="12700">
+            <a:solidFill>
+              <a:srgbClr val="2563EB"/>
+            </a:solidFill>
+          </a:ln>
+        </p:spPr>
+        <p:style>
+          <a:lnRef idx="1">
+            <a:schemeClr val="accent1"/>
+          </a:lnRef>
+          <a:fillRef idx="3">
+            <a:schemeClr val="accent1"/>
+          </a:fillRef>
+          <a:effectRef idx="2">
+            <a:schemeClr val="accent1"/>
+          </a:effectRef>
+          <a:fontRef idx="minor">
+            <a:schemeClr val="lt1"/>
+          </a:fontRef>
+        </p:style>
+        <p:txBody>
+          <a:bodyPr rtlCol="0" anchor="ctr"/>
+          <a:lstStyle/>
+          <a:p>
+            <a:pPr algn="ctr"/>
+          </a:p>
+        </p:txBody>
+      </p:sp>
+      <p:sp>
+        <p:nvSpPr>
+          <p:cNvPr id="6" name="TextBox 5"/>
+          <p:cNvSpPr txBox="1"/>
+          <p:nvPr/>
+        </p:nvSpPr>
+        <p:spPr>
+          <a:xfrm>
+            <a:off x="1005840" y="1371600"/>
+            <a:ext cx="10180015" cy="3566160"/>
+          </a:xfrm>
+          <a:prstGeom prst="rect">
+            <a:avLst/>
+          </a:prstGeom>
+          <a:noFill/>
+        </p:spPr>
+        <p:txBody>
+          <a:bodyPr wrap="square">
+            <a:spAutoFit/>
+          </a:bodyPr>
+          <a:lstStyle/>
+          <a:p>
+            <a:pPr>
+              <a:spcAft>
+                <a:spcPts val="1400"/>
+              </a:spcAft>
+              <a:defRPr sz="1600" b="1">
+                <a:solidFill>
+                  <a:srgbClr val="0F172A"/>
+                </a:solidFill>
+                <a:latin typeface="Segoe UI"/>
+              </a:defRPr>
+            </a:pPr>
+            <a:r>
+              <a:t>Heading: Classification</a:t>
+            </a:r>
+          </a:p>
+          <a:p>
+            <a:pPr>
+              <a:spcAft>
+                <a:spcPts val="1400"/>
+              </a:spcAft>
+              <a:defRPr sz="1200" b="1">
+                <a:solidFill>
+                  <a:srgbClr val="2563EB"/>
+                </a:solidFill>
+                <a:latin typeface="Segoe UI"/>
+              </a:defRPr>
+            </a:pPr>
+            <a:r>
+              <a:t>• What it is: </a:t>
+            </a:r>
+            <a:r>
+              <a:rPr sz="1200" b="0">
+                <a:solidFill>
+                  <a:srgbClr val="334155"/>
+                </a:solidFill>
+                <a:latin typeface="Segoe UI"/>
+              </a:rPr>
+              <a:t>Supervised machine learning method that categorizes borrower applications into binary outcomes (0: No Default, 1: Default).</a:t>
+            </a:r>
+          </a:p>
+          <a:p>
+            <a:pPr>
+              <a:spcAft>
+                <a:spcPts val="1400"/>
+              </a:spcAft>
+              <a:defRPr sz="1200" b="1">
+                <a:solidFill>
+                  <a:srgbClr val="2563EB"/>
+                </a:solidFill>
+                <a:latin typeface="Segoe UI"/>
+              </a:defRPr>
+            </a:pPr>
+            <a:r>
+              <a:t>• Why it is needed: </a:t>
+            </a:r>
+            <a:r>
+              <a:rPr sz="1200" b="0">
+                <a:solidFill>
+                  <a:srgbClr val="334155"/>
+                </a:solidFill>
+                <a:latin typeface="Segoe UI"/>
+              </a:rPr>
+              <a:t>Flags high-risk applicants before credit disbursement to prevent non-performing assets (NPAs) and bad-debt write-offs.</a:t>
+            </a:r>
+          </a:p>
+          <a:p>
+            <a:pPr>
+              <a:spcAft>
+                <a:spcPts val="1400"/>
+              </a:spcAft>
+              <a:defRPr sz="1200" b="1">
+                <a:solidFill>
+                  <a:srgbClr val="2563EB"/>
+                </a:solidFill>
+                <a:latin typeface="Segoe UI"/>
+              </a:defRPr>
+            </a:pPr>
+            <a:r>
+              <a:t>• Where it is used: </a:t>
+            </a:r>
+            <a:r>
+              <a:rPr sz="1200" b="0">
+                <a:solidFill>
+                  <a:srgbClr val="334155"/>
+                </a:solidFill>
+                <a:latin typeface="Segoe UI"/>
+              </a:rPr>
+              <a:t>Deployed in the initial automated credit underwriting pipeline to evaluate all incoming applicant profiles.</a:t>
+            </a:r>
+          </a:p>
+          <a:p>
+            <a:pPr>
+              <a:spcAft>
+                <a:spcPts val="1400"/>
+              </a:spcAft>
+              <a:defRPr sz="1200" b="1">
+                <a:solidFill>
+                  <a:srgbClr val="2563EB"/>
+                </a:solidFill>
+                <a:latin typeface="Segoe UI"/>
+              </a:defRPr>
+            </a:pPr>
+            <a:r>
+              <a:t>• How it is helpful: </a:t>
+            </a:r>
+            <a:r>
+              <a:rPr sz="1200" b="0">
+                <a:solidFill>
+                  <a:srgbClr val="334155"/>
+                </a:solidFill>
+                <a:latin typeface="Segoe UI"/>
+              </a:rPr>
+              <a:t>Provides fast, objective risk screening with 97.75% accuracy and an optimal 0.8965 F1-Score.</a:t>
+            </a:r>
+          </a:p>
+        </p:txBody>
+      </p:sp>
+      <p:sp>
+        <p:nvSpPr>
+          <p:cNvPr id="7" name="Rounded Rectangle 6"/>
+          <p:cNvSpPr/>
+          <p:nvPr/>
+        </p:nvSpPr>
+        <p:spPr>
+          <a:xfrm>
+            <a:off x="731520" y="5303520"/>
+            <a:ext cx="10728655" cy="1051560"/>
           </a:xfrm>
           <a:prstGeom prst="roundRect">
             <a:avLst/>
@@ -8546,14 +7433,14 @@
       </p:sp>
       <p:sp>
         <p:nvSpPr>
-          <p:cNvPr id="6" name="TextBox 5"/>
+          <p:cNvPr id="8" name="TextBox 7"/>
           <p:cNvSpPr txBox="1"/>
           <p:nvPr/>
         </p:nvSpPr>
         <p:spPr>
           <a:xfrm>
-            <a:off x="914400" y="1325880"/>
-            <a:ext cx="4846320" cy="2240280"/>
+            <a:off x="1005840" y="5394960"/>
+            <a:ext cx="10180015" cy="868680"/>
           </a:xfrm>
           <a:prstGeom prst="rect">
             <a:avLst/>
@@ -8568,9 +7455,9 @@
           <a:p>
             <a:pPr>
               <a:spcAft>
-                <a:spcPts val="800"/>
+                <a:spcPts val="200"/>
               </a:spcAft>
-              <a:defRPr sz="1300" b="1">
+              <a:defRPr sz="1200" b="1">
                 <a:solidFill>
                   <a:srgbClr val="2563EB"/>
                 </a:solidFill>
@@ -8578,451 +7465,20 @@
               </a:defRPr>
             </a:pPr>
             <a:r>
-              <a:t>1. WHY We Used It (Problem Statement)</a:t>
-            </a:r>
-          </a:p>
-          <a:p>
-            <a:pPr>
-              <a:spcAft>
-                <a:spcPts val="600"/>
-              </a:spcAft>
-              <a:defRPr sz="1200">
-                <a:solidFill>
-                  <a:srgbClr val="334155"/>
-                </a:solidFill>
-                <a:latin typeface="Segoe UI"/>
-              </a:defRPr>
-            </a:pPr>
-            <a:r>
-              <a:t>• Lending institutions suffer severe bad-debt write-offs when borrowers default.</a:t>
-            </a:r>
-          </a:p>
-          <a:p>
-            <a:pPr>
-              <a:spcAft>
-                <a:spcPts val="600"/>
-              </a:spcAft>
-              <a:defRPr sz="1200">
-                <a:solidFill>
-                  <a:srgbClr val="334155"/>
-                </a:solidFill>
-                <a:latin typeface="Segoe UI"/>
-              </a:defRPr>
-            </a:pPr>
-            <a:r>
-              <a:t>• Lenders require an automated, objective system to screen high-risk loan applicants.</a:t>
-            </a:r>
-          </a:p>
-          <a:p>
-            <a:pPr>
-              <a:spcAft>
-                <a:spcPts val="600"/>
-              </a:spcAft>
-              <a:defRPr sz="1200">
-                <a:solidFill>
-                  <a:srgbClr val="334155"/>
-                </a:solidFill>
-                <a:latin typeface="Segoe UI"/>
-              </a:defRPr>
-            </a:pPr>
-            <a:r>
-              <a:t>• Manual underwriter reviews are slow, inconsistent, and cannot scale across high loan volumes.</a:t>
-            </a:r>
-          </a:p>
-        </p:txBody>
-      </p:sp>
-      <p:sp>
-        <p:nvSpPr>
-          <p:cNvPr id="7" name="Rounded Rectangle 6"/>
-          <p:cNvSpPr/>
-          <p:nvPr/>
-        </p:nvSpPr>
-        <p:spPr>
-          <a:xfrm>
-            <a:off x="6217920" y="1188720"/>
-            <a:ext cx="5242255" cy="2514600"/>
-          </a:xfrm>
-          <a:prstGeom prst="roundRect">
-            <a:avLst/>
-          </a:prstGeom>
-          <a:solidFill>
-            <a:srgbClr val="ECFDF5"/>
-          </a:solidFill>
-          <a:ln w="12700">
-            <a:solidFill>
-              <a:srgbClr val="10B981"/>
-            </a:solidFill>
-          </a:ln>
-        </p:spPr>
-        <p:style>
-          <a:lnRef idx="1">
-            <a:schemeClr val="accent1"/>
-          </a:lnRef>
-          <a:fillRef idx="3">
-            <a:schemeClr val="accent1"/>
-          </a:fillRef>
-          <a:effectRef idx="2">
-            <a:schemeClr val="accent1"/>
-          </a:effectRef>
-          <a:fontRef idx="minor">
-            <a:schemeClr val="lt1"/>
-          </a:fontRef>
-        </p:style>
-        <p:txBody>
-          <a:bodyPr rtlCol="0" anchor="ctr"/>
-          <a:lstStyle/>
-          <a:p>
-            <a:pPr algn="ctr"/>
-          </a:p>
-        </p:txBody>
-      </p:sp>
-      <p:sp>
-        <p:nvSpPr>
-          <p:cNvPr id="8" name="TextBox 7"/>
-          <p:cNvSpPr txBox="1"/>
-          <p:nvPr/>
-        </p:nvSpPr>
-        <p:spPr>
-          <a:xfrm>
-            <a:off x="6400800" y="1325880"/>
-            <a:ext cx="4876495" cy="2240280"/>
-          </a:xfrm>
-          <a:prstGeom prst="rect">
-            <a:avLst/>
-          </a:prstGeom>
-          <a:noFill/>
-        </p:spPr>
-        <p:txBody>
-          <a:bodyPr wrap="square">
-            <a:spAutoFit/>
-          </a:bodyPr>
-          <a:lstStyle/>
-          <a:p>
-            <a:pPr>
-              <a:spcAft>
-                <a:spcPts val="800"/>
-              </a:spcAft>
-              <a:defRPr sz="1300" b="1">
-                <a:solidFill>
-                  <a:srgbClr val="10B981"/>
-                </a:solidFill>
-                <a:latin typeface="Segoe UI"/>
-              </a:defRPr>
-            </a:pPr>
-            <a:r>
-              <a:t>2. HOW We Used It (Pipeline &amp; Methods)</a:t>
-            </a:r>
-          </a:p>
-          <a:p>
-            <a:pPr>
-              <a:spcAft>
-                <a:spcPts val="600"/>
-              </a:spcAft>
-              <a:defRPr sz="1200">
-                <a:solidFill>
-                  <a:srgbClr val="334155"/>
-                </a:solidFill>
-                <a:latin typeface="Segoe UI"/>
-              </a:defRPr>
-            </a:pPr>
-            <a:r>
-              <a:t>• Benchmarked 4 supervised classifiers: Logistic Regression, Decision Tree, Random Forest, Gradient Boosting.</a:t>
-            </a:r>
-          </a:p>
-          <a:p>
-            <a:pPr>
-              <a:spcAft>
-                <a:spcPts val="600"/>
-              </a:spcAft>
-              <a:defRPr sz="1200">
-                <a:solidFill>
-                  <a:srgbClr val="334155"/>
-                </a:solidFill>
-                <a:latin typeface="Segoe UI"/>
-              </a:defRPr>
-            </a:pPr>
-            <a:r>
-              <a:t>• Handled class imbalance (11.7% default) via class-weighting and prioritized F1-Score &amp; ROC-AUC.</a:t>
-            </a:r>
-          </a:p>
-          <a:p>
-            <a:pPr>
-              <a:spcAft>
-                <a:spcPts val="600"/>
-              </a:spcAft>
-              <a:defRPr sz="1200">
-                <a:solidFill>
-                  <a:srgbClr val="334155"/>
-                </a:solidFill>
-                <a:latin typeface="Segoe UI"/>
-              </a:defRPr>
-            </a:pPr>
-            <a:r>
-              <a:t>• Evaluated on 10,000 holdout test samples with zero data leakage from training.</a:t>
-            </a:r>
-          </a:p>
-        </p:txBody>
-      </p:sp>
-      <p:sp>
-        <p:nvSpPr>
-          <p:cNvPr id="9" name="Rounded Rectangle 8"/>
-          <p:cNvSpPr/>
-          <p:nvPr/>
-        </p:nvSpPr>
-        <p:spPr>
-          <a:xfrm>
-            <a:off x="731520" y="3886200"/>
-            <a:ext cx="5212080" cy="2560320"/>
-          </a:xfrm>
-          <a:prstGeom prst="roundRect">
-            <a:avLst/>
-          </a:prstGeom>
-          <a:solidFill>
-            <a:srgbClr val="FEF9C3"/>
-          </a:solidFill>
-          <a:ln w="12700">
-            <a:solidFill>
-              <a:srgbClr val="CA8A04"/>
-            </a:solidFill>
-          </a:ln>
-        </p:spPr>
-        <p:style>
-          <a:lnRef idx="1">
-            <a:schemeClr val="accent1"/>
-          </a:lnRef>
-          <a:fillRef idx="3">
-            <a:schemeClr val="accent1"/>
-          </a:fillRef>
-          <a:effectRef idx="2">
-            <a:schemeClr val="accent1"/>
-          </a:effectRef>
-          <a:fontRef idx="minor">
-            <a:schemeClr val="lt1"/>
-          </a:fontRef>
-        </p:style>
-        <p:txBody>
-          <a:bodyPr rtlCol="0" anchor="ctr"/>
-          <a:lstStyle/>
-          <a:p>
-            <a:pPr algn="ctr"/>
-          </a:p>
-        </p:txBody>
-      </p:sp>
-      <p:sp>
-        <p:nvSpPr>
-          <p:cNvPr id="10" name="TextBox 9"/>
-          <p:cNvSpPr txBox="1"/>
-          <p:nvPr/>
-        </p:nvSpPr>
-        <p:spPr>
-          <a:xfrm>
-            <a:off x="914400" y="4023360"/>
-            <a:ext cx="4846320" cy="2286000"/>
-          </a:xfrm>
-          <a:prstGeom prst="rect">
-            <a:avLst/>
-          </a:prstGeom>
-          <a:noFill/>
-        </p:spPr>
-        <p:txBody>
-          <a:bodyPr wrap="square">
-            <a:spAutoFit/>
-          </a:bodyPr>
-          <a:lstStyle/>
-          <a:p>
-            <a:pPr>
-              <a:spcAft>
-                <a:spcPts val="800"/>
-              </a:spcAft>
-              <a:defRPr sz="1300" b="1">
-                <a:solidFill>
-                  <a:srgbClr val="CA8A04"/>
-                </a:solidFill>
-                <a:latin typeface="Segoe UI"/>
-              </a:defRPr>
-            </a:pPr>
-            <a:r>
-              <a:t>3. WHAT It Does in Our Project (System Role)</a:t>
-            </a:r>
-          </a:p>
-          <a:p>
-            <a:pPr>
-              <a:spcAft>
-                <a:spcPts val="600"/>
-              </a:spcAft>
-              <a:defRPr sz="1200">
-                <a:solidFill>
-                  <a:srgbClr val="334155"/>
-                </a:solidFill>
-                <a:latin typeface="Segoe UI"/>
-              </a:defRPr>
-            </a:pPr>
-            <a:r>
-              <a:t>• Learns complex financial risk patterns to classify applicants into Default (1) vs. No Default (0).</a:t>
-            </a:r>
-          </a:p>
-          <a:p>
-            <a:pPr>
-              <a:spcAft>
-                <a:spcPts val="600"/>
-              </a:spcAft>
-              <a:defRPr sz="1200">
-                <a:solidFill>
-                  <a:srgbClr val="334155"/>
-                </a:solidFill>
-                <a:latin typeface="Segoe UI"/>
-              </a:defRPr>
-            </a:pPr>
-            <a:r>
-              <a:t>• Identifies Gradient Boosting as champion architecture with 97.75% accuracy and 0.8965 F1-Score.</a:t>
-            </a:r>
-          </a:p>
-          <a:p>
-            <a:pPr>
-              <a:spcAft>
-                <a:spcPts val="600"/>
-              </a:spcAft>
-              <a:defRPr sz="1200">
-                <a:solidFill>
-                  <a:srgbClr val="334155"/>
-                </a:solidFill>
-                <a:latin typeface="Segoe UI"/>
-              </a:defRPr>
-            </a:pPr>
-            <a:r>
-              <a:t>• Exports the champion model into prediction/saved_models/best_classifier.joblib.</a:t>
-            </a:r>
-          </a:p>
-        </p:txBody>
-      </p:sp>
-      <p:sp>
-        <p:nvSpPr>
-          <p:cNvPr id="11" name="Rounded Rectangle 10"/>
-          <p:cNvSpPr/>
-          <p:nvPr/>
-        </p:nvSpPr>
-        <p:spPr>
-          <a:xfrm>
-            <a:off x="6217920" y="3886200"/>
-            <a:ext cx="5242255" cy="2560320"/>
-          </a:xfrm>
-          <a:prstGeom prst="roundRect">
-            <a:avLst/>
-          </a:prstGeom>
-          <a:solidFill>
-            <a:srgbClr val="F5F3FF"/>
-          </a:solidFill>
-          <a:ln w="12700">
-            <a:solidFill>
-              <a:srgbClr val="9333EA"/>
-            </a:solidFill>
-          </a:ln>
-        </p:spPr>
-        <p:style>
-          <a:lnRef idx="1">
-            <a:schemeClr val="accent1"/>
-          </a:lnRef>
-          <a:fillRef idx="3">
-            <a:schemeClr val="accent1"/>
-          </a:fillRef>
-          <a:effectRef idx="2">
-            <a:schemeClr val="accent1"/>
-          </a:effectRef>
-          <a:fontRef idx="minor">
-            <a:schemeClr val="lt1"/>
-          </a:fontRef>
-        </p:style>
-        <p:txBody>
-          <a:bodyPr rtlCol="0" anchor="ctr"/>
-          <a:lstStyle/>
-          <a:p>
-            <a:pPr algn="ctr"/>
-          </a:p>
-        </p:txBody>
-      </p:sp>
-      <p:sp>
-        <p:nvSpPr>
-          <p:cNvPr id="12" name="TextBox 11"/>
-          <p:cNvSpPr txBox="1"/>
-          <p:nvPr/>
-        </p:nvSpPr>
-        <p:spPr>
-          <a:xfrm>
-            <a:off x="6400800" y="4023360"/>
-            <a:ext cx="4876495" cy="2286000"/>
-          </a:xfrm>
-          <a:prstGeom prst="rect">
-            <a:avLst/>
-          </a:prstGeom>
-          <a:noFill/>
-        </p:spPr>
-        <p:txBody>
-          <a:bodyPr wrap="square">
-            <a:spAutoFit/>
-          </a:bodyPr>
-          <a:lstStyle/>
-          <a:p>
-            <a:pPr>
-              <a:spcAft>
-                <a:spcPts val="800"/>
-              </a:spcAft>
-              <a:defRPr sz="1300" b="1">
-                <a:solidFill>
-                  <a:srgbClr val="9333EA"/>
-                </a:solidFill>
-                <a:latin typeface="Segoe UI"/>
-              </a:defRPr>
-            </a:pPr>
-            <a:r>
-              <a:t>4. PRACTICAL USE (Underwriting &amp; Business Value)</a:t>
-            </a:r>
-          </a:p>
-          <a:p>
-            <a:pPr>
-              <a:spcAft>
-                <a:spcPts val="600"/>
-              </a:spcAft>
-              <a:defRPr sz="1200">
-                <a:solidFill>
-                  <a:srgbClr val="334155"/>
-                </a:solidFill>
-                <a:latin typeface="Segoe UI"/>
-              </a:defRPr>
-            </a:pPr>
-            <a:r>
-              <a:t>• Automated Underwriting: Fast-tracks credit approvals while instantly flagging risky loans.</a:t>
-            </a:r>
-          </a:p>
-          <a:p>
-            <a:pPr>
-              <a:spcAft>
-                <a:spcPts val="600"/>
-              </a:spcAft>
-              <a:defRPr sz="1200">
-                <a:solidFill>
-                  <a:srgbClr val="334155"/>
-                </a:solidFill>
-                <a:latin typeface="Segoe UI"/>
-              </a:defRPr>
-            </a:pPr>
-            <a:r>
-              <a:t>• Loss Prevention: Drastically slashes Non-Performing Assets (NPAs) with 97.11% precision.</a:t>
-            </a:r>
-          </a:p>
-          <a:p>
-            <a:pPr>
-              <a:spcAft>
-                <a:spcPts val="600"/>
-              </a:spcAft>
-              <a:defRPr sz="1200">
-                <a:solidFill>
-                  <a:srgbClr val="334155"/>
-                </a:solidFill>
-                <a:latin typeface="Segoe UI"/>
-              </a:defRPr>
-            </a:pPr>
-            <a:r>
-              <a:t>• Institutional Standard: Establishes a verifiable, auditable credit decision benchmark.</a:t>
+              <a:t>Project Implementation: classification/train_classifiers.py  |  Champion Result: Champion: Gradient Boosting (Accuracy: 97.75% | F1: 0.8965 | ROC-AUC: 0.9973)</a:t>
+            </a:r>
+          </a:p>
+          <a:p>
+            <a:pPr>
+              <a:defRPr sz="1100">
+                <a:solidFill>
+                  <a:srgbClr val="64748B"/>
+                </a:solidFill>
+                <a:latin typeface="Segoe UI"/>
+              </a:defRPr>
+            </a:pPr>
+            <a:r>
+              <a:t>Execution verified against Kaggle benchmark dataset (50,000 records, 18 financial features) with zero data leakage.</a:t>
             </a:r>
           </a:p>
         </p:txBody>
@@ -10635,7 +9091,7 @@
         <p:spPr>
           <a:xfrm>
             <a:off x="822960" y="1280160"/>
-            <a:ext cx="5029200" cy="4023360"/>
+            <a:ext cx="5029200" cy="4343400"/>
           </a:xfrm>
           <a:prstGeom prst="rect">
             <a:avLst/>
@@ -10912,7 +9368,7 @@
               </a:defRPr>
             </a:pPr>
             <a:r>
-              <a:t>CSI3010 | MODULE 2: CLUSTERING</a:t>
+              <a:t>CSI3010 | TOPIC OVERVIEW &amp; INSTITUTIONAL ROLE</a:t>
             </a:r>
           </a:p>
         </p:txBody>
@@ -10948,7 +9404,7 @@
               </a:defRPr>
             </a:pPr>
             <a:r>
-              <a:t>Topic 2: Clustering — Concept &amp; Institutional Role</a:t>
+              <a:t>Overview: Clustering</a:t>
             </a:r>
           </a:p>
         </p:txBody>
@@ -10962,7 +9418,191 @@
         <p:spPr>
           <a:xfrm>
             <a:off x="731520" y="1188720"/>
-            <a:ext cx="5212080" cy="2514600"/>
+            <a:ext cx="10728655" cy="3931920"/>
+          </a:xfrm>
+          <a:prstGeom prst="roundRect">
+            <a:avLst/>
+          </a:prstGeom>
+          <a:solidFill>
+            <a:srgbClr val="FFFFFF"/>
+          </a:solidFill>
+          <a:ln w="12700">
+            <a:solidFill>
+              <a:srgbClr val="2563EB"/>
+            </a:solidFill>
+          </a:ln>
+        </p:spPr>
+        <p:style>
+          <a:lnRef idx="1">
+            <a:schemeClr val="accent1"/>
+          </a:lnRef>
+          <a:fillRef idx="3">
+            <a:schemeClr val="accent1"/>
+          </a:fillRef>
+          <a:effectRef idx="2">
+            <a:schemeClr val="accent1"/>
+          </a:effectRef>
+          <a:fontRef idx="minor">
+            <a:schemeClr val="lt1"/>
+          </a:fontRef>
+        </p:style>
+        <p:txBody>
+          <a:bodyPr rtlCol="0" anchor="ctr"/>
+          <a:lstStyle/>
+          <a:p>
+            <a:pPr algn="ctr"/>
+          </a:p>
+        </p:txBody>
+      </p:sp>
+      <p:sp>
+        <p:nvSpPr>
+          <p:cNvPr id="6" name="TextBox 5"/>
+          <p:cNvSpPr txBox="1"/>
+          <p:nvPr/>
+        </p:nvSpPr>
+        <p:spPr>
+          <a:xfrm>
+            <a:off x="1005840" y="1371600"/>
+            <a:ext cx="10180015" cy="3566160"/>
+          </a:xfrm>
+          <a:prstGeom prst="rect">
+            <a:avLst/>
+          </a:prstGeom>
+          <a:noFill/>
+        </p:spPr>
+        <p:txBody>
+          <a:bodyPr wrap="square">
+            <a:spAutoFit/>
+          </a:bodyPr>
+          <a:lstStyle/>
+          <a:p>
+            <a:pPr>
+              <a:spcAft>
+                <a:spcPts val="1400"/>
+              </a:spcAft>
+              <a:defRPr sz="1600" b="1">
+                <a:solidFill>
+                  <a:srgbClr val="0F172A"/>
+                </a:solidFill>
+                <a:latin typeface="Segoe UI"/>
+              </a:defRPr>
+            </a:pPr>
+            <a:r>
+              <a:t>Heading: Clustering</a:t>
+            </a:r>
+          </a:p>
+          <a:p>
+            <a:pPr>
+              <a:spcAft>
+                <a:spcPts val="1400"/>
+              </a:spcAft>
+              <a:defRPr sz="1200" b="1">
+                <a:solidFill>
+                  <a:srgbClr val="2563EB"/>
+                </a:solidFill>
+                <a:latin typeface="Segoe UI"/>
+              </a:defRPr>
+            </a:pPr>
+            <a:r>
+              <a:t>• What it is: </a:t>
+            </a:r>
+            <a:r>
+              <a:rPr sz="1200" b="0">
+                <a:solidFill>
+                  <a:srgbClr val="334155"/>
+                </a:solidFill>
+                <a:latin typeface="Segoe UI"/>
+              </a:rPr>
+              <a:t>Unsupervised machine learning method that segments borrowers into natural risk cohorts without relying on past default labels.</a:t>
+            </a:r>
+          </a:p>
+          <a:p>
+            <a:pPr>
+              <a:spcAft>
+                <a:spcPts val="1400"/>
+              </a:spcAft>
+              <a:defRPr sz="1200" b="1">
+                <a:solidFill>
+                  <a:srgbClr val="2563EB"/>
+                </a:solidFill>
+                <a:latin typeface="Segoe UI"/>
+              </a:defRPr>
+            </a:pPr>
+            <a:r>
+              <a:t>• Why it is needed: </a:t>
+            </a:r>
+            <a:r>
+              <a:rPr sz="1200" b="0">
+                <a:solidFill>
+                  <a:srgbClr val="334155"/>
+                </a:solidFill>
+                <a:latin typeface="Segoe UI"/>
+              </a:rPr>
+              <a:t>Captures diverse borrower archetypes across multiple financial indicators (Income, Credit Score, DTI, Employment Tenure).</a:t>
+            </a:r>
+          </a:p>
+          <a:p>
+            <a:pPr>
+              <a:spcAft>
+                <a:spcPts val="1400"/>
+              </a:spcAft>
+              <a:defRPr sz="1200" b="1">
+                <a:solidFill>
+                  <a:srgbClr val="2563EB"/>
+                </a:solidFill>
+                <a:latin typeface="Segoe UI"/>
+              </a:defRPr>
+            </a:pPr>
+            <a:r>
+              <a:t>• Where it is used: </a:t>
+            </a:r>
+            <a:r>
+              <a:rPr sz="1200" b="0">
+                <a:solidFill>
+                  <a:srgbClr val="334155"/>
+                </a:solidFill>
+                <a:latin typeface="Segoe UI"/>
+              </a:rPr>
+              <a:t>Applied in credit portfolio segmentation, regulatory capital reserve allocations, and customer risk profiling.</a:t>
+            </a:r>
+          </a:p>
+          <a:p>
+            <a:pPr>
+              <a:spcAft>
+                <a:spcPts val="1400"/>
+              </a:spcAft>
+              <a:defRPr sz="1200" b="1">
+                <a:solidFill>
+                  <a:srgbClr val="2563EB"/>
+                </a:solidFill>
+                <a:latin typeface="Segoe UI"/>
+              </a:defRPr>
+            </a:pPr>
+            <a:r>
+              <a:t>• How it is helpful: </a:t>
+            </a:r>
+            <a:r>
+              <a:rPr sz="1200" b="0">
+                <a:solidFill>
+                  <a:srgbClr val="334155"/>
+                </a:solidFill>
+                <a:latin typeface="Segoe UI"/>
+              </a:rPr>
+              <a:t>Enables tailored interest rate pricing, tiered credit limits, and targeted early-intervention counseling for vulnerable borrowers.</a:t>
+            </a:r>
+          </a:p>
+        </p:txBody>
+      </p:sp>
+      <p:sp>
+        <p:nvSpPr>
+          <p:cNvPr id="7" name="Rounded Rectangle 6"/>
+          <p:cNvSpPr/>
+          <p:nvPr/>
+        </p:nvSpPr>
+        <p:spPr>
+          <a:xfrm>
+            <a:off x="731520" y="5303520"/>
+            <a:ext cx="10728655" cy="1051560"/>
           </a:xfrm>
           <a:prstGeom prst="roundRect">
             <a:avLst/>
@@ -11000,14 +9640,14 @@
       </p:sp>
       <p:sp>
         <p:nvSpPr>
-          <p:cNvPr id="6" name="TextBox 5"/>
+          <p:cNvPr id="8" name="TextBox 7"/>
           <p:cNvSpPr txBox="1"/>
           <p:nvPr/>
         </p:nvSpPr>
         <p:spPr>
           <a:xfrm>
-            <a:off x="914400" y="1325880"/>
-            <a:ext cx="4846320" cy="2240280"/>
+            <a:off x="1005840" y="5394960"/>
+            <a:ext cx="10180015" cy="868680"/>
           </a:xfrm>
           <a:prstGeom prst="rect">
             <a:avLst/>
@@ -11022,9 +9662,9 @@
           <a:p>
             <a:pPr>
               <a:spcAft>
-                <a:spcPts val="800"/>
+                <a:spcPts val="200"/>
               </a:spcAft>
-              <a:defRPr sz="1300" b="1">
+              <a:defRPr sz="1200" b="1">
                 <a:solidFill>
                   <a:srgbClr val="2563EB"/>
                 </a:solidFill>
@@ -11032,451 +9672,20 @@
               </a:defRPr>
             </a:pPr>
             <a:r>
-              <a:t>1. WHY We Used It (Problem Statement)</a:t>
-            </a:r>
-          </a:p>
-          <a:p>
-            <a:pPr>
-              <a:spcAft>
-                <a:spcPts val="600"/>
-              </a:spcAft>
-              <a:defRPr sz="1200">
-                <a:solidFill>
-                  <a:srgbClr val="334155"/>
-                </a:solidFill>
-                <a:latin typeface="Segoe UI"/>
-              </a:defRPr>
-            </a:pPr>
-            <a:r>
-              <a:t>• Credit risk is not a flat binary outcome; borrowers have diverse financial archetypes.</a:t>
-            </a:r>
-          </a:p>
-          <a:p>
-            <a:pPr>
-              <a:spcAft>
-                <a:spcPts val="600"/>
-              </a:spcAft>
-              <a:defRPr sz="1200">
-                <a:solidFill>
-                  <a:srgbClr val="334155"/>
-                </a:solidFill>
-                <a:latin typeface="Segoe UI"/>
-              </a:defRPr>
-            </a:pPr>
-            <a:r>
-              <a:t>• Lenders need to discover natural customer segments without relying on past default labels.</a:t>
-            </a:r>
-          </a:p>
-          <a:p>
-            <a:pPr>
-              <a:spcAft>
-                <a:spcPts val="600"/>
-              </a:spcAft>
-              <a:defRPr sz="1200">
-                <a:solidFill>
-                  <a:srgbClr val="334155"/>
-                </a:solidFill>
-                <a:latin typeface="Segoe UI"/>
-              </a:defRPr>
-            </a:pPr>
-            <a:r>
-              <a:t>• Helps underwriters identify subtle risk buildup before defaults formally occur.</a:t>
-            </a:r>
-          </a:p>
-        </p:txBody>
-      </p:sp>
-      <p:sp>
-        <p:nvSpPr>
-          <p:cNvPr id="7" name="Rounded Rectangle 6"/>
-          <p:cNvSpPr/>
-          <p:nvPr/>
-        </p:nvSpPr>
-        <p:spPr>
-          <a:xfrm>
-            <a:off x="6217920" y="1188720"/>
-            <a:ext cx="5242255" cy="2514600"/>
-          </a:xfrm>
-          <a:prstGeom prst="roundRect">
-            <a:avLst/>
-          </a:prstGeom>
-          <a:solidFill>
-            <a:srgbClr val="ECFDF5"/>
-          </a:solidFill>
-          <a:ln w="12700">
-            <a:solidFill>
-              <a:srgbClr val="10B981"/>
-            </a:solidFill>
-          </a:ln>
-        </p:spPr>
-        <p:style>
-          <a:lnRef idx="1">
-            <a:schemeClr val="accent1"/>
-          </a:lnRef>
-          <a:fillRef idx="3">
-            <a:schemeClr val="accent1"/>
-          </a:fillRef>
-          <a:effectRef idx="2">
-            <a:schemeClr val="accent1"/>
-          </a:effectRef>
-          <a:fontRef idx="minor">
-            <a:schemeClr val="lt1"/>
-          </a:fontRef>
-        </p:style>
-        <p:txBody>
-          <a:bodyPr rtlCol="0" anchor="ctr"/>
-          <a:lstStyle/>
-          <a:p>
-            <a:pPr algn="ctr"/>
-          </a:p>
-        </p:txBody>
-      </p:sp>
-      <p:sp>
-        <p:nvSpPr>
-          <p:cNvPr id="8" name="TextBox 7"/>
-          <p:cNvSpPr txBox="1"/>
-          <p:nvPr/>
-        </p:nvSpPr>
-        <p:spPr>
-          <a:xfrm>
-            <a:off x="6400800" y="1325880"/>
-            <a:ext cx="4876495" cy="2240280"/>
-          </a:xfrm>
-          <a:prstGeom prst="rect">
-            <a:avLst/>
-          </a:prstGeom>
-          <a:noFill/>
-        </p:spPr>
-        <p:txBody>
-          <a:bodyPr wrap="square">
-            <a:spAutoFit/>
-          </a:bodyPr>
-          <a:lstStyle/>
-          <a:p>
-            <a:pPr>
-              <a:spcAft>
-                <a:spcPts val="800"/>
-              </a:spcAft>
-              <a:defRPr sz="1300" b="1">
-                <a:solidFill>
-                  <a:srgbClr val="10B981"/>
-                </a:solidFill>
-                <a:latin typeface="Segoe UI"/>
-              </a:defRPr>
-            </a:pPr>
-            <a:r>
-              <a:t>2. HOW We Used It (Pipeline &amp; Methods)</a:t>
-            </a:r>
-          </a:p>
-          <a:p>
-            <a:pPr>
-              <a:spcAft>
-                <a:spcPts val="600"/>
-              </a:spcAft>
-              <a:defRPr sz="1200">
-                <a:solidFill>
-                  <a:srgbClr val="334155"/>
-                </a:solidFill>
-                <a:latin typeface="Segoe UI"/>
-              </a:defRPr>
-            </a:pPr>
-            <a:r>
-              <a:t>• Standardized 5 core numerical features: Income, CreditScore, LoanAmount, DTIRatio, MonthsEmployed.</a:t>
-            </a:r>
-          </a:p>
-          <a:p>
-            <a:pPr>
-              <a:spcAft>
-                <a:spcPts val="600"/>
-              </a:spcAft>
-              <a:defRPr sz="1200">
-                <a:solidFill>
-                  <a:srgbClr val="334155"/>
-                </a:solidFill>
-                <a:latin typeface="Segoe UI"/>
-              </a:defRPr>
-            </a:pPr>
-            <a:r>
-              <a:t>• Trained K-Means clustering across K=2 to 6, evaluating within-cluster inertia and Silhouette scores.</a:t>
-            </a:r>
-          </a:p>
-          <a:p>
-            <a:pPr>
-              <a:spcAft>
-                <a:spcPts val="600"/>
-              </a:spcAft>
-              <a:defRPr sz="1200">
-                <a:solidFill>
-                  <a:srgbClr val="334155"/>
-                </a:solidFill>
-                <a:latin typeface="Segoe UI"/>
-              </a:defRPr>
-            </a:pPr>
-            <a:r>
-              <a:t>• Identified optimal K=3 at the Elbow curve inflection point and validated cluster cohesion.</a:t>
-            </a:r>
-          </a:p>
-        </p:txBody>
-      </p:sp>
-      <p:sp>
-        <p:nvSpPr>
-          <p:cNvPr id="9" name="Rounded Rectangle 8"/>
-          <p:cNvSpPr/>
-          <p:nvPr/>
-        </p:nvSpPr>
-        <p:spPr>
-          <a:xfrm>
-            <a:off x="731520" y="3886200"/>
-            <a:ext cx="5212080" cy="2560320"/>
-          </a:xfrm>
-          <a:prstGeom prst="roundRect">
-            <a:avLst/>
-          </a:prstGeom>
-          <a:solidFill>
-            <a:srgbClr val="FEF9C3"/>
-          </a:solidFill>
-          <a:ln w="12700">
-            <a:solidFill>
-              <a:srgbClr val="CA8A04"/>
-            </a:solidFill>
-          </a:ln>
-        </p:spPr>
-        <p:style>
-          <a:lnRef idx="1">
-            <a:schemeClr val="accent1"/>
-          </a:lnRef>
-          <a:fillRef idx="3">
-            <a:schemeClr val="accent1"/>
-          </a:fillRef>
-          <a:effectRef idx="2">
-            <a:schemeClr val="accent1"/>
-          </a:effectRef>
-          <a:fontRef idx="minor">
-            <a:schemeClr val="lt1"/>
-          </a:fontRef>
-        </p:style>
-        <p:txBody>
-          <a:bodyPr rtlCol="0" anchor="ctr"/>
-          <a:lstStyle/>
-          <a:p>
-            <a:pPr algn="ctr"/>
-          </a:p>
-        </p:txBody>
-      </p:sp>
-      <p:sp>
-        <p:nvSpPr>
-          <p:cNvPr id="10" name="TextBox 9"/>
-          <p:cNvSpPr txBox="1"/>
-          <p:nvPr/>
-        </p:nvSpPr>
-        <p:spPr>
-          <a:xfrm>
-            <a:off x="914400" y="4023360"/>
-            <a:ext cx="4846320" cy="2286000"/>
-          </a:xfrm>
-          <a:prstGeom prst="rect">
-            <a:avLst/>
-          </a:prstGeom>
-          <a:noFill/>
-        </p:spPr>
-        <p:txBody>
-          <a:bodyPr wrap="square">
-            <a:spAutoFit/>
-          </a:bodyPr>
-          <a:lstStyle/>
-          <a:p>
-            <a:pPr>
-              <a:spcAft>
-                <a:spcPts val="800"/>
-              </a:spcAft>
-              <a:defRPr sz="1300" b="1">
-                <a:solidFill>
-                  <a:srgbClr val="CA8A04"/>
-                </a:solidFill>
-                <a:latin typeface="Segoe UI"/>
-              </a:defRPr>
-            </a:pPr>
-            <a:r>
-              <a:t>3. WHAT It Does in Our Project (System Role)</a:t>
-            </a:r>
-          </a:p>
-          <a:p>
-            <a:pPr>
-              <a:spcAft>
-                <a:spcPts val="600"/>
-              </a:spcAft>
-              <a:defRPr sz="1200">
-                <a:solidFill>
-                  <a:srgbClr val="334155"/>
-                </a:solidFill>
-                <a:latin typeface="Segoe UI"/>
-              </a:defRPr>
-            </a:pPr>
-            <a:r>
-              <a:t>• Groups 50,000 borrowers into 3 natural, interpretable risk profiles (Prime, Standard, Vulnerable).</a:t>
-            </a:r>
-          </a:p>
-          <a:p>
-            <a:pPr>
-              <a:spcAft>
-                <a:spcPts val="600"/>
-              </a:spcAft>
-              <a:defRPr sz="1200">
-                <a:solidFill>
-                  <a:srgbClr val="334155"/>
-                </a:solidFill>
-                <a:latin typeface="Segoe UI"/>
-              </a:defRPr>
-            </a:pPr>
-            <a:r>
-              <a:t>• Discovers that default rates differ by over 5x between clusters (3.93% vs. 20.36%) without using default labels during training.</a:t>
-            </a:r>
-          </a:p>
-          <a:p>
-            <a:pPr>
-              <a:spcAft>
-                <a:spcPts val="600"/>
-              </a:spcAft>
-              <a:defRPr sz="1200">
-                <a:solidFill>
-                  <a:srgbClr val="334155"/>
-                </a:solidFill>
-                <a:latin typeface="Segoe UI"/>
-              </a:defRPr>
-            </a:pPr>
-            <a:r>
-              <a:t>• Projects the 5D feature space into 2D PCA components for geometric risk space visualization.</a:t>
-            </a:r>
-          </a:p>
-        </p:txBody>
-      </p:sp>
-      <p:sp>
-        <p:nvSpPr>
-          <p:cNvPr id="11" name="Rounded Rectangle 10"/>
-          <p:cNvSpPr/>
-          <p:nvPr/>
-        </p:nvSpPr>
-        <p:spPr>
-          <a:xfrm>
-            <a:off x="6217920" y="3886200"/>
-            <a:ext cx="5242255" cy="2560320"/>
-          </a:xfrm>
-          <a:prstGeom prst="roundRect">
-            <a:avLst/>
-          </a:prstGeom>
-          <a:solidFill>
-            <a:srgbClr val="F5F3FF"/>
-          </a:solidFill>
-          <a:ln w="12700">
-            <a:solidFill>
-              <a:srgbClr val="9333EA"/>
-            </a:solidFill>
-          </a:ln>
-        </p:spPr>
-        <p:style>
-          <a:lnRef idx="1">
-            <a:schemeClr val="accent1"/>
-          </a:lnRef>
-          <a:fillRef idx="3">
-            <a:schemeClr val="accent1"/>
-          </a:fillRef>
-          <a:effectRef idx="2">
-            <a:schemeClr val="accent1"/>
-          </a:effectRef>
-          <a:fontRef idx="minor">
-            <a:schemeClr val="lt1"/>
-          </a:fontRef>
-        </p:style>
-        <p:txBody>
-          <a:bodyPr rtlCol="0" anchor="ctr"/>
-          <a:lstStyle/>
-          <a:p>
-            <a:pPr algn="ctr"/>
-          </a:p>
-        </p:txBody>
-      </p:sp>
-      <p:sp>
-        <p:nvSpPr>
-          <p:cNvPr id="12" name="TextBox 11"/>
-          <p:cNvSpPr txBox="1"/>
-          <p:nvPr/>
-        </p:nvSpPr>
-        <p:spPr>
-          <a:xfrm>
-            <a:off x="6400800" y="4023360"/>
-            <a:ext cx="4876495" cy="2286000"/>
-          </a:xfrm>
-          <a:prstGeom prst="rect">
-            <a:avLst/>
-          </a:prstGeom>
-          <a:noFill/>
-        </p:spPr>
-        <p:txBody>
-          <a:bodyPr wrap="square">
-            <a:spAutoFit/>
-          </a:bodyPr>
-          <a:lstStyle/>
-          <a:p>
-            <a:pPr>
-              <a:spcAft>
-                <a:spcPts val="800"/>
-              </a:spcAft>
-              <a:defRPr sz="1300" b="1">
-                <a:solidFill>
-                  <a:srgbClr val="9333EA"/>
-                </a:solidFill>
-                <a:latin typeface="Segoe UI"/>
-              </a:defRPr>
-            </a:pPr>
-            <a:r>
-              <a:t>4. PRACTICAL USE (Underwriting &amp; Business Value)</a:t>
-            </a:r>
-          </a:p>
-          <a:p>
-            <a:pPr>
-              <a:spcAft>
-                <a:spcPts val="600"/>
-              </a:spcAft>
-              <a:defRPr sz="1200">
-                <a:solidFill>
-                  <a:srgbClr val="334155"/>
-                </a:solidFill>
-                <a:latin typeface="Segoe UI"/>
-              </a:defRPr>
-            </a:pPr>
-            <a:r>
-              <a:t>• Risk-Based Portfolio Pricing: Sets tailored interest rates and borrowing limits per tier.</a:t>
-            </a:r>
-          </a:p>
-          <a:p>
-            <a:pPr>
-              <a:spcAft>
-                <a:spcPts val="600"/>
-              </a:spcAft>
-              <a:defRPr sz="1200">
-                <a:solidFill>
-                  <a:srgbClr val="334155"/>
-                </a:solidFill>
-                <a:latin typeface="Segoe UI"/>
-              </a:defRPr>
-            </a:pPr>
-            <a:r>
-              <a:t>• Proactive Portfolio Monitoring: Targets vulnerable cohorts with financial counseling before defaults trigger.</a:t>
-            </a:r>
-          </a:p>
-          <a:p>
-            <a:pPr>
-              <a:spcAft>
-                <a:spcPts val="600"/>
-              </a:spcAft>
-              <a:defRPr sz="1200">
-                <a:solidFill>
-                  <a:srgbClr val="334155"/>
-                </a:solidFill>
-                <a:latin typeface="Segoe UI"/>
-              </a:defRPr>
-            </a:pPr>
-            <a:r>
-              <a:t>• Capital Allocation: Banks allocate capital reserves based on cluster risk concentrations.</a:t>
+              <a:t>Project Implementation: clustering/train_clustering.py  |  Champion Result: Optimal K=3 (Prime: 3.93% default, Standard: 12.38%, Subprime: 20.36%)</a:t>
+            </a:r>
+          </a:p>
+          <a:p>
+            <a:pPr>
+              <a:defRPr sz="1100">
+                <a:solidFill>
+                  <a:srgbClr val="64748B"/>
+                </a:solidFill>
+                <a:latin typeface="Segoe UI"/>
+              </a:defRPr>
+            </a:pPr>
+            <a:r>
+              <a:t>Execution verified against Kaggle benchmark dataset (50,000 records, 18 financial features) with zero data leakage.</a:t>
             </a:r>
           </a:p>
         </p:txBody>
@@ -13135,7 +11344,7 @@
               </a:defRPr>
             </a:pPr>
             <a:r>
-              <a:t>CSI3010 | MODULE 3: ASSOCIATION RULES</a:t>
+              <a:t>CSI3010 | TOPIC OVERVIEW &amp; INSTITUTIONAL ROLE</a:t>
             </a:r>
           </a:p>
         </p:txBody>
@@ -13171,7 +11380,7 @@
               </a:defRPr>
             </a:pPr>
             <a:r>
-              <a:t>Topic 3: Association Rules — Concept &amp; Institutional Role</a:t>
+              <a:t>Overview: Association Rules</a:t>
             </a:r>
           </a:p>
         </p:txBody>
@@ -13185,7 +11394,191 @@
         <p:spPr>
           <a:xfrm>
             <a:off x="731520" y="1188720"/>
-            <a:ext cx="5212080" cy="2514600"/>
+            <a:ext cx="10728655" cy="3931920"/>
+          </a:xfrm>
+          <a:prstGeom prst="roundRect">
+            <a:avLst/>
+          </a:prstGeom>
+          <a:solidFill>
+            <a:srgbClr val="FFFFFF"/>
+          </a:solidFill>
+          <a:ln w="12700">
+            <a:solidFill>
+              <a:srgbClr val="2563EB"/>
+            </a:solidFill>
+          </a:ln>
+        </p:spPr>
+        <p:style>
+          <a:lnRef idx="1">
+            <a:schemeClr val="accent1"/>
+          </a:lnRef>
+          <a:fillRef idx="3">
+            <a:schemeClr val="accent1"/>
+          </a:fillRef>
+          <a:effectRef idx="2">
+            <a:schemeClr val="accent1"/>
+          </a:effectRef>
+          <a:fontRef idx="minor">
+            <a:schemeClr val="lt1"/>
+          </a:fontRef>
+        </p:style>
+        <p:txBody>
+          <a:bodyPr rtlCol="0" anchor="ctr"/>
+          <a:lstStyle/>
+          <a:p>
+            <a:pPr algn="ctr"/>
+          </a:p>
+        </p:txBody>
+      </p:sp>
+      <p:sp>
+        <p:nvSpPr>
+          <p:cNvPr id="6" name="TextBox 5"/>
+          <p:cNvSpPr txBox="1"/>
+          <p:nvPr/>
+        </p:nvSpPr>
+        <p:spPr>
+          <a:xfrm>
+            <a:off x="1005840" y="1371600"/>
+            <a:ext cx="10180015" cy="3566160"/>
+          </a:xfrm>
+          <a:prstGeom prst="rect">
+            <a:avLst/>
+          </a:prstGeom>
+          <a:noFill/>
+        </p:spPr>
+        <p:txBody>
+          <a:bodyPr wrap="square">
+            <a:spAutoFit/>
+          </a:bodyPr>
+          <a:lstStyle/>
+          <a:p>
+            <a:pPr>
+              <a:spcAft>
+                <a:spcPts val="1400"/>
+              </a:spcAft>
+              <a:defRPr sz="1600" b="1">
+                <a:solidFill>
+                  <a:srgbClr val="0F172A"/>
+                </a:solidFill>
+                <a:latin typeface="Segoe UI"/>
+              </a:defRPr>
+            </a:pPr>
+            <a:r>
+              <a:t>Heading: Association Rules</a:t>
+            </a:r>
+          </a:p>
+          <a:p>
+            <a:pPr>
+              <a:spcAft>
+                <a:spcPts val="1400"/>
+              </a:spcAft>
+              <a:defRPr sz="1200" b="1">
+                <a:solidFill>
+                  <a:srgbClr val="2563EB"/>
+                </a:solidFill>
+                <a:latin typeface="Segoe UI"/>
+              </a:defRPr>
+            </a:pPr>
+            <a:r>
+              <a:t>• What it is: </a:t>
+            </a:r>
+            <a:r>
+              <a:rPr sz="1200" b="0">
+                <a:solidFill>
+                  <a:srgbClr val="334155"/>
+                </a:solidFill>
+                <a:latin typeface="Segoe UI"/>
+              </a:rPr>
+              <a:t>Data mining rule-discovery technique (Apriori) extracting non-trivial IF-THEN relationships between co-occurring loan features.</a:t>
+            </a:r>
+          </a:p>
+          <a:p>
+            <a:pPr>
+              <a:spcAft>
+                <a:spcPts val="1400"/>
+              </a:spcAft>
+              <a:defRPr sz="1200" b="1">
+                <a:solidFill>
+                  <a:srgbClr val="2563EB"/>
+                </a:solidFill>
+                <a:latin typeface="Segoe UI"/>
+              </a:defRPr>
+            </a:pPr>
+            <a:r>
+              <a:t>• Why it is needed: </a:t>
+            </a:r>
+            <a:r>
+              <a:rPr sz="1200" b="0">
+                <a:solidFill>
+                  <a:srgbClr val="334155"/>
+                </a:solidFill>
+                <a:latin typeface="Segoe UI"/>
+              </a:rPr>
+              <a:t>Uncovers multi-attribute risk combinations (e.g. low income + poor credit + high DTI) that linear scorecards fail to detect.</a:t>
+            </a:r>
+          </a:p>
+          <a:p>
+            <a:pPr>
+              <a:spcAft>
+                <a:spcPts val="1400"/>
+              </a:spcAft>
+              <a:defRPr sz="1200" b="1">
+                <a:solidFill>
+                  <a:srgbClr val="2563EB"/>
+                </a:solidFill>
+                <a:latin typeface="Segoe UI"/>
+              </a:defRPr>
+            </a:pPr>
+            <a:r>
+              <a:t>• Where it is used: </a:t>
+            </a:r>
+            <a:r>
+              <a:rPr sz="1200" b="0">
+                <a:solidFill>
+                  <a:srgbClr val="334155"/>
+                </a:solidFill>
+                <a:latin typeface="Segoe UI"/>
+              </a:rPr>
+              <a:t>Integrated into automated credit policy rule engines, underwriter red-flag checklists, and policy threshold triggers.</a:t>
+            </a:r>
+          </a:p>
+          <a:p>
+            <a:pPr>
+              <a:spcAft>
+                <a:spcPts val="1400"/>
+              </a:spcAft>
+              <a:defRPr sz="1200" b="1">
+                <a:solidFill>
+                  <a:srgbClr val="2563EB"/>
+                </a:solidFill>
+                <a:latin typeface="Segoe UI"/>
+              </a:defRPr>
+            </a:pPr>
+            <a:r>
+              <a:t>• How it is helpful: </a:t>
+            </a:r>
+            <a:r>
+              <a:rPr sz="1200" b="0">
+                <a:solidFill>
+                  <a:srgbClr val="334155"/>
+                </a:solidFill>
+                <a:latin typeface="Segoe UI"/>
+              </a:rPr>
+              <a:t>Pinpoints toxic feature combinations multiplying default risk up to 5.69x over baseline and isolates the risk-reducing impact of co-signers.</a:t>
+            </a:r>
+          </a:p>
+        </p:txBody>
+      </p:sp>
+      <p:sp>
+        <p:nvSpPr>
+          <p:cNvPr id="7" name="Rounded Rectangle 6"/>
+          <p:cNvSpPr/>
+          <p:nvPr/>
+        </p:nvSpPr>
+        <p:spPr>
+          <a:xfrm>
+            <a:off x="731520" y="5303520"/>
+            <a:ext cx="10728655" cy="1051560"/>
           </a:xfrm>
           <a:prstGeom prst="roundRect">
             <a:avLst/>
@@ -13223,14 +11616,14 @@
       </p:sp>
       <p:sp>
         <p:nvSpPr>
-          <p:cNvPr id="6" name="TextBox 5"/>
+          <p:cNvPr id="8" name="TextBox 7"/>
           <p:cNvSpPr txBox="1"/>
           <p:nvPr/>
         </p:nvSpPr>
         <p:spPr>
           <a:xfrm>
-            <a:off x="914400" y="1325880"/>
-            <a:ext cx="4846320" cy="2240280"/>
+            <a:off x="1005840" y="5394960"/>
+            <a:ext cx="10180015" cy="868680"/>
           </a:xfrm>
           <a:prstGeom prst="rect">
             <a:avLst/>
@@ -13245,9 +11638,9 @@
           <a:p>
             <a:pPr>
               <a:spcAft>
-                <a:spcPts val="800"/>
+                <a:spcPts val="200"/>
               </a:spcAft>
-              <a:defRPr sz="1300" b="1">
+              <a:defRPr sz="1200" b="1">
                 <a:solidFill>
                   <a:srgbClr val="2563EB"/>
                 </a:solidFill>
@@ -13255,451 +11648,20 @@
               </a:defRPr>
             </a:pPr>
             <a:r>
-              <a:t>1. WHY We Used It (Problem Statement)</a:t>
-            </a:r>
-          </a:p>
-          <a:p>
-            <a:pPr>
-              <a:spcAft>
-                <a:spcPts val="600"/>
-              </a:spcAft>
-              <a:defRPr sz="1200">
-                <a:solidFill>
-                  <a:srgbClr val="334155"/>
-                </a:solidFill>
-                <a:latin typeface="Segoe UI"/>
-              </a:defRPr>
-            </a:pPr>
-            <a:r>
-              <a:t>• Loan defaults are rarely triggered by a single parameter in isolation.</a:t>
-            </a:r>
-          </a:p>
-          <a:p>
-            <a:pPr>
-              <a:spcAft>
-                <a:spcPts val="600"/>
-              </a:spcAft>
-              <a:defRPr sz="1200">
-                <a:solidFill>
-                  <a:srgbClr val="334155"/>
-                </a:solidFill>
-                <a:latin typeface="Segoe UI"/>
-              </a:defRPr>
-            </a:pPr>
-            <a:r>
-              <a:t>• Defaults happen when multiple adverse financial traits combine (e.g. low income + high DTI + poor credit).</a:t>
-            </a:r>
-          </a:p>
-          <a:p>
-            <a:pPr>
-              <a:spcAft>
-                <a:spcPts val="600"/>
-              </a:spcAft>
-              <a:defRPr sz="1200">
-                <a:solidFill>
-                  <a:srgbClr val="334155"/>
-                </a:solidFill>
-                <a:latin typeface="Segoe UI"/>
-              </a:defRPr>
-            </a:pPr>
-            <a:r>
-              <a:t>• Traditional linear scorecards fail to capture non-linear, multi-condition risk interactions.</a:t>
-            </a:r>
-          </a:p>
-        </p:txBody>
-      </p:sp>
-      <p:sp>
-        <p:nvSpPr>
-          <p:cNvPr id="7" name="Rounded Rectangle 6"/>
-          <p:cNvSpPr/>
-          <p:nvPr/>
-        </p:nvSpPr>
-        <p:spPr>
-          <a:xfrm>
-            <a:off x="6217920" y="1188720"/>
-            <a:ext cx="5242255" cy="2514600"/>
-          </a:xfrm>
-          <a:prstGeom prst="roundRect">
-            <a:avLst/>
-          </a:prstGeom>
-          <a:solidFill>
-            <a:srgbClr val="ECFDF5"/>
-          </a:solidFill>
-          <a:ln w="12700">
-            <a:solidFill>
-              <a:srgbClr val="10B981"/>
-            </a:solidFill>
-          </a:ln>
-        </p:spPr>
-        <p:style>
-          <a:lnRef idx="1">
-            <a:schemeClr val="accent1"/>
-          </a:lnRef>
-          <a:fillRef idx="3">
-            <a:schemeClr val="accent1"/>
-          </a:fillRef>
-          <a:effectRef idx="2">
-            <a:schemeClr val="accent1"/>
-          </a:effectRef>
-          <a:fontRef idx="minor">
-            <a:schemeClr val="lt1"/>
-          </a:fontRef>
-        </p:style>
-        <p:txBody>
-          <a:bodyPr rtlCol="0" anchor="ctr"/>
-          <a:lstStyle/>
-          <a:p>
-            <a:pPr algn="ctr"/>
-          </a:p>
-        </p:txBody>
-      </p:sp>
-      <p:sp>
-        <p:nvSpPr>
-          <p:cNvPr id="8" name="TextBox 7"/>
-          <p:cNvSpPr txBox="1"/>
-          <p:nvPr/>
-        </p:nvSpPr>
-        <p:spPr>
-          <a:xfrm>
-            <a:off x="6400800" y="1325880"/>
-            <a:ext cx="4876495" cy="2240280"/>
-          </a:xfrm>
-          <a:prstGeom prst="rect">
-            <a:avLst/>
-          </a:prstGeom>
-          <a:noFill/>
-        </p:spPr>
-        <p:txBody>
-          <a:bodyPr wrap="square">
-            <a:spAutoFit/>
-          </a:bodyPr>
-          <a:lstStyle/>
-          <a:p>
-            <a:pPr>
-              <a:spcAft>
-                <a:spcPts val="800"/>
-              </a:spcAft>
-              <a:defRPr sz="1300" b="1">
-                <a:solidFill>
-                  <a:srgbClr val="10B981"/>
-                </a:solidFill>
-                <a:latin typeface="Segoe UI"/>
-              </a:defRPr>
-            </a:pPr>
-            <a:r>
-              <a:t>2. HOW We Used It (Pipeline &amp; Methods)</a:t>
-            </a:r>
-          </a:p>
-          <a:p>
-            <a:pPr>
-              <a:spcAft>
-                <a:spcPts val="600"/>
-              </a:spcAft>
-              <a:defRPr sz="1200">
-                <a:solidFill>
-                  <a:srgbClr val="334155"/>
-                </a:solidFill>
-                <a:latin typeface="Segoe UI"/>
-              </a:defRPr>
-            </a:pPr>
-            <a:r>
-              <a:t>• Discretized continuous metrics into domain bins (Income tertiles, Credit tiers, DTI brackets).</a:t>
-            </a:r>
-          </a:p>
-          <a:p>
-            <a:pPr>
-              <a:spcAft>
-                <a:spcPts val="600"/>
-              </a:spcAft>
-              <a:defRPr sz="1200">
-                <a:solidFill>
-                  <a:srgbClr val="334155"/>
-                </a:solidFill>
-                <a:latin typeface="Segoe UI"/>
-              </a:defRPr>
-            </a:pPr>
-            <a:r>
-              <a:t>• Applied the Apriori Algorithm (mlxtend) to mine frequent itemsets across 15,000 transactions.</a:t>
-            </a:r>
-          </a:p>
-          <a:p>
-            <a:pPr>
-              <a:spcAft>
-                <a:spcPts val="600"/>
-              </a:spcAft>
-              <a:defRPr sz="1200">
-                <a:solidFill>
-                  <a:srgbClr val="334155"/>
-                </a:solidFill>
-                <a:latin typeface="Segoe UI"/>
-              </a:defRPr>
-            </a:pPr>
-            <a:r>
-              <a:t>• Evaluated Support, Confidence, and Lift, filtering specifically for consequent Default=Yes.</a:t>
-            </a:r>
-          </a:p>
-        </p:txBody>
-      </p:sp>
-      <p:sp>
-        <p:nvSpPr>
-          <p:cNvPr id="9" name="Rounded Rectangle 8"/>
-          <p:cNvSpPr/>
-          <p:nvPr/>
-        </p:nvSpPr>
-        <p:spPr>
-          <a:xfrm>
-            <a:off x="731520" y="3886200"/>
-            <a:ext cx="5212080" cy="2560320"/>
-          </a:xfrm>
-          <a:prstGeom prst="roundRect">
-            <a:avLst/>
-          </a:prstGeom>
-          <a:solidFill>
-            <a:srgbClr val="FEF9C3"/>
-          </a:solidFill>
-          <a:ln w="12700">
-            <a:solidFill>
-              <a:srgbClr val="CA8A04"/>
-            </a:solidFill>
-          </a:ln>
-        </p:spPr>
-        <p:style>
-          <a:lnRef idx="1">
-            <a:schemeClr val="accent1"/>
-          </a:lnRef>
-          <a:fillRef idx="3">
-            <a:schemeClr val="accent1"/>
-          </a:fillRef>
-          <a:effectRef idx="2">
-            <a:schemeClr val="accent1"/>
-          </a:effectRef>
-          <a:fontRef idx="minor">
-            <a:schemeClr val="lt1"/>
-          </a:fontRef>
-        </p:style>
-        <p:txBody>
-          <a:bodyPr rtlCol="0" anchor="ctr"/>
-          <a:lstStyle/>
-          <a:p>
-            <a:pPr algn="ctr"/>
-          </a:p>
-        </p:txBody>
-      </p:sp>
-      <p:sp>
-        <p:nvSpPr>
-          <p:cNvPr id="10" name="TextBox 9"/>
-          <p:cNvSpPr txBox="1"/>
-          <p:nvPr/>
-        </p:nvSpPr>
-        <p:spPr>
-          <a:xfrm>
-            <a:off x="914400" y="4023360"/>
-            <a:ext cx="4846320" cy="2286000"/>
-          </a:xfrm>
-          <a:prstGeom prst="rect">
-            <a:avLst/>
-          </a:prstGeom>
-          <a:noFill/>
-        </p:spPr>
-        <p:txBody>
-          <a:bodyPr wrap="square">
-            <a:spAutoFit/>
-          </a:bodyPr>
-          <a:lstStyle/>
-          <a:p>
-            <a:pPr>
-              <a:spcAft>
-                <a:spcPts val="800"/>
-              </a:spcAft>
-              <a:defRPr sz="1300" b="1">
-                <a:solidFill>
-                  <a:srgbClr val="CA8A04"/>
-                </a:solidFill>
-                <a:latin typeface="Segoe UI"/>
-              </a:defRPr>
-            </a:pPr>
-            <a:r>
-              <a:t>3. WHAT It Does in Our Project (System Role)</a:t>
-            </a:r>
-          </a:p>
-          <a:p>
-            <a:pPr>
-              <a:spcAft>
-                <a:spcPts val="600"/>
-              </a:spcAft>
-              <a:defRPr sz="1200">
-                <a:solidFill>
-                  <a:srgbClr val="334155"/>
-                </a:solidFill>
-                <a:latin typeface="Segoe UI"/>
-              </a:defRPr>
-            </a:pPr>
-            <a:r>
-              <a:t>• Discovers non-trivial IF-THEN borrower risk patterns with statistical conviction.</a:t>
-            </a:r>
-          </a:p>
-          <a:p>
-            <a:pPr>
-              <a:spcAft>
-                <a:spcPts val="600"/>
-              </a:spcAft>
-              <a:defRPr sz="1200">
-                <a:solidFill>
-                  <a:srgbClr val="334155"/>
-                </a:solidFill>
-                <a:latin typeface="Segoe UI"/>
-              </a:defRPr>
-            </a:pPr>
-            <a:r>
-              <a:t>• Reveals that specific feature combinations increase default risk by over 5.69 times compared to random applicants.</a:t>
-            </a:r>
-          </a:p>
-          <a:p>
-            <a:pPr>
-              <a:spcAft>
-                <a:spcPts val="600"/>
-              </a:spcAft>
-              <a:defRPr sz="1200">
-                <a:solidFill>
-                  <a:srgbClr val="334155"/>
-                </a:solidFill>
-                <a:latin typeface="Segoe UI"/>
-              </a:defRPr>
-            </a:pPr>
-            <a:r>
-              <a:t>• Quantifies the protective impact of loan co-signers in mitigating default risk.</a:t>
-            </a:r>
-          </a:p>
-        </p:txBody>
-      </p:sp>
-      <p:sp>
-        <p:nvSpPr>
-          <p:cNvPr id="11" name="Rounded Rectangle 10"/>
-          <p:cNvSpPr/>
-          <p:nvPr/>
-        </p:nvSpPr>
-        <p:spPr>
-          <a:xfrm>
-            <a:off x="6217920" y="3886200"/>
-            <a:ext cx="5242255" cy="2560320"/>
-          </a:xfrm>
-          <a:prstGeom prst="roundRect">
-            <a:avLst/>
-          </a:prstGeom>
-          <a:solidFill>
-            <a:srgbClr val="F5F3FF"/>
-          </a:solidFill>
-          <a:ln w="12700">
-            <a:solidFill>
-              <a:srgbClr val="9333EA"/>
-            </a:solidFill>
-          </a:ln>
-        </p:spPr>
-        <p:style>
-          <a:lnRef idx="1">
-            <a:schemeClr val="accent1"/>
-          </a:lnRef>
-          <a:fillRef idx="3">
-            <a:schemeClr val="accent1"/>
-          </a:fillRef>
-          <a:effectRef idx="2">
-            <a:schemeClr val="accent1"/>
-          </a:effectRef>
-          <a:fontRef idx="minor">
-            <a:schemeClr val="lt1"/>
-          </a:fontRef>
-        </p:style>
-        <p:txBody>
-          <a:bodyPr rtlCol="0" anchor="ctr"/>
-          <a:lstStyle/>
-          <a:p>
-            <a:pPr algn="ctr"/>
-          </a:p>
-        </p:txBody>
-      </p:sp>
-      <p:sp>
-        <p:nvSpPr>
-          <p:cNvPr id="12" name="TextBox 11"/>
-          <p:cNvSpPr txBox="1"/>
-          <p:nvPr/>
-        </p:nvSpPr>
-        <p:spPr>
-          <a:xfrm>
-            <a:off x="6400800" y="4023360"/>
-            <a:ext cx="4876495" cy="2286000"/>
-          </a:xfrm>
-          <a:prstGeom prst="rect">
-            <a:avLst/>
-          </a:prstGeom>
-          <a:noFill/>
-        </p:spPr>
-        <p:txBody>
-          <a:bodyPr wrap="square">
-            <a:spAutoFit/>
-          </a:bodyPr>
-          <a:lstStyle/>
-          <a:p>
-            <a:pPr>
-              <a:spcAft>
-                <a:spcPts val="800"/>
-              </a:spcAft>
-              <a:defRPr sz="1300" b="1">
-                <a:solidFill>
-                  <a:srgbClr val="9333EA"/>
-                </a:solidFill>
-                <a:latin typeface="Segoe UI"/>
-              </a:defRPr>
-            </a:pPr>
-            <a:r>
-              <a:t>4. PRACTICAL USE (Underwriting &amp; Business Value)</a:t>
-            </a:r>
-          </a:p>
-          <a:p>
-            <a:pPr>
-              <a:spcAft>
-                <a:spcPts val="600"/>
-              </a:spcAft>
-              <a:defRPr sz="1200">
-                <a:solidFill>
-                  <a:srgbClr val="334155"/>
-                </a:solidFill>
-                <a:latin typeface="Segoe UI"/>
-              </a:defRPr>
-            </a:pPr>
-            <a:r>
-              <a:t>• Underwriting Rule Engine: Automates policy rules (e.g. require collateral if Rule #1 triggers).</a:t>
-            </a:r>
-          </a:p>
-          <a:p>
-            <a:pPr>
-              <a:spcAft>
-                <a:spcPts val="600"/>
-              </a:spcAft>
-              <a:defRPr sz="1200">
-                <a:solidFill>
-                  <a:srgbClr val="334155"/>
-                </a:solidFill>
-                <a:latin typeface="Segoe UI"/>
-              </a:defRPr>
-            </a:pPr>
-            <a:r>
-              <a:t>• Underwriting Red Flags: Equips credit officers with an actionable risk checklist.</a:t>
-            </a:r>
-          </a:p>
-          <a:p>
-            <a:pPr>
-              <a:spcAft>
-                <a:spcPts val="600"/>
-              </a:spcAft>
-              <a:defRPr sz="1200">
-                <a:solidFill>
-                  <a:srgbClr val="334155"/>
-                </a:solidFill>
-                <a:latin typeface="Segoe UI"/>
-              </a:defRPr>
-            </a:pPr>
-            <a:r>
-              <a:t>• Policy Tuning: Informs credit committee policies on maximum loan sizes for low-income brackets.</a:t>
+              <a:t>Project Implementation: association_rules/mine_rules.py  |  Champion Result: Top Rule Lift = 5.69x (Confidence: 66.93% | Support: 3.94%)</a:t>
+            </a:r>
+          </a:p>
+          <a:p>
+            <a:pPr>
+              <a:defRPr sz="1100">
+                <a:solidFill>
+                  <a:srgbClr val="64748B"/>
+                </a:solidFill>
+                <a:latin typeface="Segoe UI"/>
+              </a:defRPr>
+            </a:pPr>
+            <a:r>
+              <a:t>Execution verified against Kaggle benchmark dataset (50,000 records, 18 financial features) with zero data leakage.</a:t>
             </a:r>
           </a:p>
         </p:txBody>
@@ -14030,324 +11992,4 @@
   </a:objectDefaults>
   <a:extraClrSchemeLst/>
 </a:theme>
-</file>
-
-<file path=ppt/theme/theme2.xml><?xml version="1.0" encoding="utf-8"?>
-<a:theme xmlns:a="http://schemas.openxmlformats.org/drawingml/2006/main" name="Office Theme">
-  <a:themeElements>
-    <a:clrScheme name="Office">
-      <a:dk1>
-        <a:sysClr val="windowText" lastClr="000000"/>
-      </a:dk1>
-      <a:lt1>
-        <a:sysClr val="window" lastClr="FFFFFF"/>
-      </a:lt1>
-      <a:dk2>
-        <a:srgbClr val="1F497D"/>
-      </a:dk2>
-      <a:lt2>
-        <a:srgbClr val="EEECE1"/>
-      </a:lt2>
-      <a:accent1>
-        <a:srgbClr val="4F81BD"/>
-      </a:accent1>
-      <a:accent2>
-        <a:srgbClr val="C0504D"/>
-      </a:accent2>
-      <a:accent3>
-        <a:srgbClr val="9BBB59"/>
-      </a:accent3>
-      <a:accent4>
-        <a:srgbClr val="8064A2"/>
-      </a:accent4>
-      <a:accent5>
-        <a:srgbClr val="4BACC6"/>
-      </a:accent5>
-      <a:accent6>
-        <a:srgbClr val="F79646"/>
-      </a:accent6>
-      <a:hlink>
-        <a:srgbClr val="0000FF"/>
-      </a:hlink>
-      <a:folHlink>
-        <a:srgbClr val="800080"/>
-      </a:folHlink>
-    </a:clrScheme>
-    <a:fontScheme name="Office">
-      <a:majorFont>
-        <a:latin typeface="Calibri"/>
-        <a:ea typeface=""/>
-        <a:cs typeface=""/>
-        <a:font script="Jpan" typeface="ＭＳ Ｐゴシック"/>
-        <a:font script="Hang" typeface="맑은 고딕"/>
-        <a:font script="Hans" typeface="宋体"/>
-        <a:font script="Hant" typeface="新細明體"/>
-        <a:font script="Arab" typeface="Times New Roman"/>
-        <a:font script="Hebr" typeface="Times New Roman"/>
-        <a:font script="Thai" typeface="Angsana New"/>
-        <a:font script="Ethi" typeface="Nyala"/>
-        <a:font script="Beng" typeface="Vrinda"/>
-        <a:font script="Gujr" typeface="Shruti"/>
-        <a:font script="Khmr" typeface="MoolBoran"/>
-        <a:font script="Knda" typeface="Tunga"/>
-        <a:font script="Guru" typeface="Raavi"/>
-        <a:font script="Cans" typeface="Euphemia"/>
-        <a:font script="Cher" typeface="Plantagenet Cherokee"/>
-        <a:font script="Yiii" typeface="Microsoft Yi Baiti"/>
-        <a:font script="Tibt" typeface="Microsoft Himalaya"/>
-        <a:font script="Thaa" typeface="MV Boli"/>
-        <a:font script="Deva" typeface="Mangal"/>
-        <a:font script="Telu" typeface="Gautami"/>
-        <a:font script="Taml" typeface="Latha"/>
-        <a:font script="Syrc" typeface="Estrangelo Edessa"/>
-        <a:font script="Orya" typeface="Kalinga"/>
-        <a:font script="Mlym" typeface="Kartika"/>
-        <a:font script="Laoo" typeface="DokChampa"/>
-        <a:font script="Sinh" typeface="Iskoola Pota"/>
-        <a:font script="Mong" typeface="Mongolian Baiti"/>
-        <a:font script="Viet" typeface="Times New Roman"/>
-        <a:font script="Uigh" typeface="Microsoft Uighur"/>
-        <a:font script="Geor" typeface="Sylfaen"/>
-      </a:majorFont>
-      <a:minorFont>
-        <a:latin typeface="Calibri"/>
-        <a:ea typeface=""/>
-        <a:cs typeface=""/>
-        <a:font script="Jpan" typeface="ＭＳ Ｐゴシック"/>
-        <a:font script="Hang" typeface="맑은 고딕"/>
-        <a:font script="Hans" typeface="宋体"/>
-        <a:font script="Hant" typeface="新細明體"/>
-        <a:font script="Arab" typeface="Arial"/>
-        <a:font script="Hebr" typeface="Arial"/>
-        <a:font script="Thai" typeface="Cordia New"/>
-        <a:font script="Ethi" typeface="Nyala"/>
-        <a:font script="Beng" typeface="Vrinda"/>
-        <a:font script="Gujr" typeface="Shruti"/>
-        <a:font script="Khmr" typeface="DaunPenh"/>
-        <a:font script="Knda" typeface="Tunga"/>
-        <a:font script="Guru" typeface="Raavi"/>
-        <a:font script="Cans" typeface="Euphemia"/>
-        <a:font script="Cher" typeface="Plantagenet Cherokee"/>
-        <a:font script="Yiii" typeface="Microsoft Yi Baiti"/>
-        <a:font script="Tibt" typeface="Microsoft Himalaya"/>
-        <a:font script="Thaa" typeface="MV Boli"/>
-        <a:font script="Deva" typeface="Mangal"/>
-        <a:font script="Telu" typeface="Gautami"/>
-        <a:font script="Taml" typeface="Latha"/>
-        <a:font script="Syrc" typeface="Estrangelo Edessa"/>
-        <a:font script="Orya" typeface="Kalinga"/>
-        <a:font script="Mlym" typeface="Kartika"/>
-        <a:font script="Laoo" typeface="DokChampa"/>
-        <a:font script="Sinh" typeface="Iskoola Pota"/>
-        <a:font script="Mong" typeface="Mongolian Baiti"/>
-        <a:font script="Viet" typeface="Arial"/>
-        <a:font script="Uigh" typeface="Microsoft Uighur"/>
-        <a:font script="Geor" typeface="Sylfaen"/>
-      </a:minorFont>
-    </a:fontScheme>
-    <a:fmtScheme name="Office">
-      <a:fillStyleLst>
-        <a:solidFill>
-          <a:schemeClr val="phClr"/>
-        </a:solidFill>
-        <a:gradFill rotWithShape="1">
-          <a:gsLst>
-            <a:gs pos="0">
-              <a:schemeClr val="phClr">
-                <a:tint val="50000"/>
-                <a:satMod val="300000"/>
-              </a:schemeClr>
-            </a:gs>
-            <a:gs pos="35000">
-              <a:schemeClr val="phClr">
-                <a:tint val="37000"/>
-                <a:satMod val="300000"/>
-              </a:schemeClr>
-            </a:gs>
-            <a:gs pos="100000">
-              <a:schemeClr val="phClr">
-                <a:tint val="15000"/>
-                <a:satMod val="350000"/>
-              </a:schemeClr>
-            </a:gs>
-          </a:gsLst>
-          <a:lin ang="16200000" scaled="1"/>
-        </a:gradFill>
-        <a:gradFill rotWithShape="1">
-          <a:gsLst>
-            <a:gs pos="0">
-              <a:schemeClr val="phClr">
-                <a:tint val="100000"/>
-                <a:shade val="100000"/>
-                <a:satMod val="130000"/>
-              </a:schemeClr>
-            </a:gs>
-            <a:gs pos="100000">
-              <a:schemeClr val="phClr">
-                <a:tint val="50000"/>
-                <a:shade val="100000"/>
-                <a:satMod val="350000"/>
-              </a:schemeClr>
-            </a:gs>
-          </a:gsLst>
-          <a:lin ang="16200000" scaled="0"/>
-        </a:gradFill>
-      </a:fillStyleLst>
-      <a:lnStyleLst>
-        <a:ln w="9525" cap="flat" cmpd="sng" algn="ctr">
-          <a:solidFill>
-            <a:schemeClr val="phClr">
-              <a:shade val="95000"/>
-              <a:satMod val="105000"/>
-            </a:schemeClr>
-          </a:solidFill>
-          <a:prstDash val="solid"/>
-        </a:ln>
-        <a:ln w="25400" cap="flat" cmpd="sng" algn="ctr">
-          <a:solidFill>
-            <a:schemeClr val="phClr"/>
-          </a:solidFill>
-          <a:prstDash val="solid"/>
-        </a:ln>
-        <a:ln w="38100" cap="flat" cmpd="sng" algn="ctr">
-          <a:solidFill>
-            <a:schemeClr val="phClr"/>
-          </a:solidFill>
-          <a:prstDash val="solid"/>
-        </a:ln>
-      </a:lnStyleLst>
-      <a:effectStyleLst>
-        <a:effectStyle>
-          <a:effectLst>
-            <a:outerShdw blurRad="40000" dist="20000" dir="5400000" rotWithShape="0">
-              <a:srgbClr val="000000">
-                <a:alpha val="38000"/>
-              </a:srgbClr>
-            </a:outerShdw>
-          </a:effectLst>
-        </a:effectStyle>
-        <a:effectStyle>
-          <a:effectLst>
-            <a:outerShdw blurRad="40000" dist="23000" dir="5400000" rotWithShape="0">
-              <a:srgbClr val="000000">
-                <a:alpha val="35000"/>
-              </a:srgbClr>
-            </a:outerShdw>
-          </a:effectLst>
-        </a:effectStyle>
-        <a:effectStyle>
-          <a:effectLst>
-            <a:outerShdw blurRad="40000" dist="23000" dir="5400000" rotWithShape="0">
-              <a:srgbClr val="000000">
-                <a:alpha val="35000"/>
-              </a:srgbClr>
-            </a:outerShdw>
-          </a:effectLst>
-          <a:scene3d>
-            <a:camera prst="orthographicFront">
-              <a:rot lat="0" lon="0" rev="0"/>
-            </a:camera>
-            <a:lightRig rig="threePt" dir="t">
-              <a:rot lat="0" lon="0" rev="1200000"/>
-            </a:lightRig>
-          </a:scene3d>
-          <a:sp3d>
-            <a:bevelT w="63500" h="25400"/>
-          </a:sp3d>
-        </a:effectStyle>
-      </a:effectStyleLst>
-      <a:bgFillStyleLst>
-        <a:solidFill>
-          <a:schemeClr val="phClr"/>
-        </a:solidFill>
-        <a:gradFill rotWithShape="1">
-          <a:gsLst>
-            <a:gs pos="0">
-              <a:schemeClr val="phClr">
-                <a:tint val="40000"/>
-                <a:satMod val="350000"/>
-              </a:schemeClr>
-            </a:gs>
-            <a:gs pos="40000">
-              <a:schemeClr val="phClr">
-                <a:tint val="45000"/>
-                <a:shade val="99000"/>
-                <a:satMod val="350000"/>
-              </a:schemeClr>
-            </a:gs>
-            <a:gs pos="100000">
-              <a:schemeClr val="phClr">
-                <a:shade val="20000"/>
-                <a:satMod val="255000"/>
-              </a:schemeClr>
-            </a:gs>
-          </a:gsLst>
-          <a:path path="circle">
-            <a:fillToRect l="50000" t="-80000" r="50000" b="180000"/>
-          </a:path>
-        </a:gradFill>
-        <a:gradFill rotWithShape="1">
-          <a:gsLst>
-            <a:gs pos="0">
-              <a:schemeClr val="phClr">
-                <a:tint val="80000"/>
-                <a:satMod val="300000"/>
-              </a:schemeClr>
-            </a:gs>
-            <a:gs pos="100000">
-              <a:schemeClr val="phClr">
-                <a:shade val="30000"/>
-                <a:satMod val="200000"/>
-              </a:schemeClr>
-            </a:gs>
-          </a:gsLst>
-          <a:path path="circle">
-            <a:fillToRect l="50000" t="50000" r="50000" b="50000"/>
-          </a:path>
-        </a:gradFill>
-      </a:bgFillStyleLst>
-    </a:fmtScheme>
-  </a:themeElements>
-  <a:objectDefaults>
-    <a:spDef>
-      <a:spPr/>
-      <a:bodyPr/>
-      <a:lstStyle/>
-      <a:style>
-        <a:lnRef idx="1">
-          <a:schemeClr val="accent1"/>
-        </a:lnRef>
-        <a:fillRef idx="3">
-          <a:schemeClr val="accent1"/>
-        </a:fillRef>
-        <a:effectRef idx="2">
-          <a:schemeClr val="accent1"/>
-        </a:effectRef>
-        <a:fontRef idx="minor">
-          <a:schemeClr val="lt1"/>
-        </a:fontRef>
-      </a:style>
-    </a:spDef>
-    <a:lnDef>
-      <a:spPr/>
-      <a:bodyPr/>
-      <a:lstStyle/>
-      <a:style>
-        <a:lnRef idx="2">
-          <a:schemeClr val="accent1"/>
-        </a:lnRef>
-        <a:fillRef idx="0">
-          <a:schemeClr val="accent1"/>
-        </a:fillRef>
-        <a:effectRef idx="1">
-          <a:schemeClr val="accent1"/>
-        </a:effectRef>
-        <a:fontRef idx="minor">
-          <a:schemeClr val="tx1"/>
-        </a:fontRef>
-      </a:style>
-    </a:lnDef>
-  </a:objectDefaults>
-  <a:extraClrSchemeLst/>
-</a:theme>
 </file>
</xml_diff>